<commit_message>
feat: expand Roadster deck to 8 slides with brand look, source links, and animation v2
Adds the Q&A structure from the class sheet, Tesla-style palette and native-shape icons,
an open-license photo placeholder, source links to the official news video and Hebrew
articles, and a more detailed 42-second animation. Unverified items are marked.

Co-Authored-By: Claude Haiku 5.5 <noreply@anthropic.com>
Claude-Session: https://claude.ai/code/session_01G3huG3JPrcdx52VhUnY5q1
</commit_message>
<xml_diff>
--- a/01-personal/tesla-roadster-kids/tesla-roadster-kids.pptx
+++ b/01-personal/tesla-roadster-kids/tesla-roadster-kids.pptx
@@ -10,6 +10,9 @@
     <p:sldId id="258" r:id="rId10"/>
     <p:sldId id="259" r:id="rId11"/>
     <p:sldId id="260" r:id="rId12"/>
+    <p:sldId id="261" r:id="rId13"/>
+    <p:sldId id="262" r:id="rId14"/>
+    <p:sldId id="263" r:id="rId15"/>
   </p:sldIdLst>
   <p:sldSz cx="12191695" cy="6858000" type="screen4x3"/>
   <p:notesSz cx="6858000" cy="9144000"/>
@@ -512,7 +515,7 @@
           <a:p/>
           <a:p>
             <a:r>
-              <a:t>מקורות לבדיקה: https://www.cnn.com/2026/10/16/world/video/tesla-unveils-what-it-says-is-a-flying-car ; https://www.statesman.com/business/article/tesla-roadster-mcgregor-flying-car-musk-spacex-22480443.php</a:t>
+              <a:t>מקורות: https://www.cnn.com/2026/10/16/world/video/tesla-unveils-what-it-says-is-a-flying-car ; https://www.statesman.com/business/article/tesla-roadster-mcgregor-flying-car-musk-spacex-22480443.php</a:t>
             </a:r>
           </a:p>
         </p:txBody>
@@ -582,7 +585,7 @@
           <a:lstStyle/>
           <a:p>
             <a:r>
-              <a:t>מקורות: https://www.cnn.com/2026/10/16/world/video/tesla-unveils-what-it-says-is-a-flying-car (הקפיצה והמומחה), https://www.statesman.com/business/article/tesla-roadster-mcgregor-flying-car-musk-spacex-22480443.php (התהפכות על הרמפה). 'ללא נהג' מופיע במקורות משניים בלבד (Wikipedia ו-Tech Insider), יש לאמת.</a:t>
+              <a:t>מקורות: https://www.cnn.com/2026/10/16/world/video/tesla-unveils-what-it-says-is-a-flying-car (קפיצה קצרה, לא טיסה ממושכת, לפי מומחה בתעופה), https://www.statesman.com/business/article/tesla-roadster-mcgregor-flying-car-musk-spacex-22480443.php (הרמפה והתהפכות).</a:t>
             </a:r>
           </a:p>
         </p:txBody>
@@ -652,22 +655,7 @@
           <a:lstStyle/>
           <a:p>
             <a:r>
-              <a:t>הסרטון הוא אנימציה המבוססת על תיאורי ההדגמה, לא צילום של ההדגמה.</a:t>
-            </a:r>
-          </a:p>
-          <a:p>
-            <a:r>
-              <a:t>מאווררים מתחת לרכב ואחיזה על הרמפה: לפי טסלה, כמתואר ב-https://www.statesman.com/business/article/tesla-roadster-mcgregor-flying-car-musk-spacex-22480443.php .</a:t>
-            </a:r>
-          </a:p>
-          <a:p>
-            <a:r>
-              <a:t>סילוני הגז: https://aviationweek.com/aerospace/emerging-technologies/tesla-demos-flying-roadster-powered-spacex-cold-gas-thrusters . מקורות שונים מדווחים על 10 פתחים (מוסק), על 4 מאחור ועוד 6 בגרסת Rocket, ועל 4 סילונים בלבד. לכן לא פירטנו את המספר בשקף.</a:t>
-            </a:r>
-          </a:p>
-          <a:p>
-            <a:r>
-              <a:t>הזמן 0-60 של 0.81 שנייה הוא מספר של טסלה ו-Aviation Week, והמשפט 'פחות משנייה' הוא של מוסק. אלה טענות של החברה בלבד, ולא נכללו בשקף.</a:t>
+              <a:t>מקורות: https://driveteslacanada.ca/news/tesla-roadster-unveiling-livestream-october-15-2026/ ; https://arynews.tv/tesla-to-unveil-long-delayed-roadster-on-october-1-musk-says (דחייה מ-1 באוקטובר בגלל מזג אוויר). הפרט 'חמישי' נלקח מאותם דיווחים: 15 באוקטובר 2026 חל ביום חמישי. מיקום: מתקן SpaceX ב-McGregor, טקסס.</a:t>
             </a:r>
           </a:p>
         </p:txBody>
@@ -737,12 +725,7 @@
           <a:lstStyle/>
           <a:p>
             <a:r>
-              <a:t>מקורות: https://www.cnn.com/2026/10/16/world/video/tesla-unveils-what-it-says-is-a-flying-car (FAA, 2028), https://www.statesman.com/business/article/tesla-roadster-mcgregor-flying-car-musk-spacex-22480443.php (הזמנות ללא הבטחה, מומחה לחוק), https://www.nbcnews.com/tech/tech-news/elon-musk-shows-flying-tesla-roadster-years-delays-rcna603905 (ההיסטוריה של העיכובים).</a:t>
-            </a:r>
-          </a:p>
-          <a:p>
-            <a:r>
-              <a:t>לפני ההצגה: בדקו את עדכוני ההשקה באתר טסלה, כי מועדים אלה עלולים להשתנות.</a:t>
+              <a:t>מקורות לתפקידים: https://builtin.com/articles/elon-musk (סקירה כללית, לאמת). הדיווחים על תפקידיו העדכניים לא תואמים זה את זה, ולכן כדאי לאמת מול אתר טסלה ו-SpaceX לפני ההצגה. תמונה: יש להוסיף קובץ images/musk.jpg רק אחרי שבדקתם את הרישיון (למשל Wikimedia Commons), ולרשום את הקרדיט ב-images/CREDIT.txt.</a:t>
             </a:r>
           </a:p>
         </p:txBody>
@@ -812,7 +795,247 @@
           <a:lstStyle/>
           <a:p>
             <a:r>
-              <a:t>סיום: תנו לכל ילד לענות בקצרה. אפשר לחבר לשאלה את הפער בין הדגמה למוצר זמין, מהשקף על מתי נקבל אותה.</a:t>
+              <a:t>הסרטון הוא אנימציה המבוססת על תיאורי ההדגמה, לא צילום שלה.</a:t>
+            </a:r>
+          </a:p>
+          <a:p>
+            <a:r>
+              <a:t>מאווררים וגז קר: לפי טסלה, כמתואר ב-https://www.statesman.com/business/article/tesla-roadster-mcgregor-flying-car-musk-spacex-22480443.php ; https://aviationweek.com/aerospace/emerging-technologies/tesla-demos-flying-roadster-powered-spacex-cold-gas-thrusters .</a:t>
+            </a:r>
+          </a:p>
+          <a:p>
+            <a:r>
+              <a:t>מספר הפתחים: מוסק דיבר על 10 פתחים, דיווח אחר על 4 מאחור ועוד 6 בגרסת Rocket. לכן לא פירטנו את המספר.</a:t>
+            </a:r>
+          </a:p>
+          <a:p>
+            <a:r>
+              <a:t>זמן 0-60 של 0.81 שנייה הוא מספר של טסלה ו-Aviation Week. 'פחות משנייה' הוא של מוסק. אלה טענות של החברה, ולכן לא הופיעו בשקף.</a:t>
+            </a:r>
+          </a:p>
+        </p:txBody>
+      </p:sp>
+      <p:sp>
+        <p:nvSpPr>
+          <p:cNvPr id="4" name="Slide Number Placeholder 3"/>
+          <p:cNvSpPr>
+            <a:spLocks noGrp="1"/>
+          </p:cNvSpPr>
+          <p:nvPr>
+            <p:ph type="sldNum" idx="5" sz="quarter"/>
+          </p:nvPr>
+        </p:nvSpPr>
+        <p:spPr/>
+      </p:sp>
+    </p:spTree>
+  </p:cSld>
+  <p:clrMapOvr>
+    <a:masterClrMapping/>
+  </p:clrMapOvr>
+</p:notes>
+</file>
+
+<file path=ppt/notesSlides/notesSlide6.xml><?xml version="1.0" encoding="utf-8"?>
+<p:notes xmlns:a="http://schemas.openxmlformats.org/drawingml/2006/main" xmlns:p="http://schemas.openxmlformats.org/presentationml/2006/main" xmlns:r="http://schemas.openxmlformats.org/officeDocument/2006/relationships">
+  <p:cSld>
+    <p:spTree>
+      <p:nvGrpSpPr>
+        <p:cNvPr id="1" name=""/>
+        <p:cNvGrpSpPr/>
+        <p:nvPr/>
+      </p:nvGrpSpPr>
+      <p:grpSpPr>
+        <a:xfrm>
+          <a:off x="0" y="0"/>
+          <a:ext cx="0" cy="0"/>
+          <a:chOff x="0" y="0"/>
+          <a:chExt cx="0" cy="0"/>
+        </a:xfrm>
+      </p:grpSpPr>
+      <p:sp>
+        <p:nvSpPr>
+          <p:cNvPr id="2" name="Slide Image Placeholder 1"/>
+          <p:cNvSpPr>
+            <a:spLocks noGrp="1"/>
+          </p:cNvSpPr>
+          <p:nvPr>
+            <p:ph type="sldImg" idx="2"/>
+          </p:nvPr>
+        </p:nvSpPr>
+        <p:spPr/>
+      </p:sp>
+      <p:sp>
+        <p:nvSpPr>
+          <p:cNvPr id="3" name="Notes Placeholder 2"/>
+          <p:cNvSpPr>
+            <a:spLocks noGrp="1"/>
+          </p:cNvSpPr>
+          <p:nvPr>
+            <p:ph type="body" idx="3" sz="quarter"/>
+          </p:nvPr>
+        </p:nvSpPr>
+        <p:spPr/>
+        <p:txBody>
+          <a:bodyPr/>
+          <a:lstStyle/>
+          <a:p>
+            <a:r>
+              <a:t>הדעה בשקף היא דעה קבוצתית, לא של כל ילד בנפרד. יש לנסח אותה מחדש עם הקבוצה לפני ההצגה.</a:t>
+            </a:r>
+          </a:p>
+          <a:p>
+            <a:r>
+              <a:t>הטענה 'מוביל חכם וחדשן' היא דעה. הטענה 'מביא פיתוחים לעולם' נתמכת במידה רבה על ידי המקורות על טסלה ו-SpaceX.</a:t>
+            </a:r>
+          </a:p>
+          <a:p>
+            <a:r>
+              <a:t>טסלה לא הייתה הרכב החשמלי הראשון, ולכן לא כתבנו שהיא הראשונה. הטענה 'עשיר מאוד' הוסרה כי לא אומתה במקור.</a:t>
+            </a:r>
+          </a:p>
+        </p:txBody>
+      </p:sp>
+      <p:sp>
+        <p:nvSpPr>
+          <p:cNvPr id="4" name="Slide Number Placeholder 3"/>
+          <p:cNvSpPr>
+            <a:spLocks noGrp="1"/>
+          </p:cNvSpPr>
+          <p:nvPr>
+            <p:ph type="sldNum" idx="5" sz="quarter"/>
+          </p:nvPr>
+        </p:nvSpPr>
+        <p:spPr/>
+      </p:sp>
+    </p:spTree>
+  </p:cSld>
+  <p:clrMapOvr>
+    <a:masterClrMapping/>
+  </p:clrMapOvr>
+</p:notes>
+</file>
+
+<file path=ppt/notesSlides/notesSlide7.xml><?xml version="1.0" encoding="utf-8"?>
+<p:notes xmlns:a="http://schemas.openxmlformats.org/drawingml/2006/main" xmlns:p="http://schemas.openxmlformats.org/presentationml/2006/main" xmlns:r="http://schemas.openxmlformats.org/officeDocument/2006/relationships">
+  <p:cSld>
+    <p:spTree>
+      <p:nvGrpSpPr>
+        <p:cNvPr id="1" name=""/>
+        <p:cNvGrpSpPr/>
+        <p:nvPr/>
+      </p:nvGrpSpPr>
+      <p:grpSpPr>
+        <a:xfrm>
+          <a:off x="0" y="0"/>
+          <a:ext cx="0" cy="0"/>
+          <a:chOff x="0" y="0"/>
+          <a:chExt cx="0" cy="0"/>
+        </a:xfrm>
+      </p:grpSpPr>
+      <p:sp>
+        <p:nvSpPr>
+          <p:cNvPr id="2" name="Slide Image Placeholder 1"/>
+          <p:cNvSpPr>
+            <a:spLocks noGrp="1"/>
+          </p:cNvSpPr>
+          <p:nvPr>
+            <p:ph type="sldImg" idx="2"/>
+          </p:nvPr>
+        </p:nvSpPr>
+        <p:spPr/>
+      </p:sp>
+      <p:sp>
+        <p:nvSpPr>
+          <p:cNvPr id="3" name="Notes Placeholder 2"/>
+          <p:cNvSpPr>
+            <a:spLocks noGrp="1"/>
+          </p:cNvSpPr>
+          <p:nvPr>
+            <p:ph type="body" idx="3" sz="quarter"/>
+          </p:nvPr>
+        </p:nvSpPr>
+        <p:spPr/>
+        <p:txBody>
+          <a:bodyPr/>
+          <a:lstStyle/>
+          <a:p>
+            <a:r>
+              <a:t>קישורים: https://www.cnn.com/2026/10/16/world/video/tesla-unveils-what-it-says-is-a-flying-car (סרטון), https://www.i24news.tv/he/news/science-and-technology/artc-28d73fdd (כתבה בעברית). כתבה נוספת בעברית: https://www.ice.co.il/auto/news/article/1133858 . לפני ההצגה, פתחו את הקישורים ובדקו שהם עדיין פעילים. הסרטון לא מוטמע כי הוא חומר מוגן זכויות.</a:t>
+            </a:r>
+          </a:p>
+        </p:txBody>
+      </p:sp>
+      <p:sp>
+        <p:nvSpPr>
+          <p:cNvPr id="4" name="Slide Number Placeholder 3"/>
+          <p:cNvSpPr>
+            <a:spLocks noGrp="1"/>
+          </p:cNvSpPr>
+          <p:nvPr>
+            <p:ph type="sldNum" idx="5" sz="quarter"/>
+          </p:nvPr>
+        </p:nvSpPr>
+        <p:spPr/>
+      </p:sp>
+    </p:spTree>
+  </p:cSld>
+  <p:clrMapOvr>
+    <a:masterClrMapping/>
+  </p:clrMapOvr>
+</p:notes>
+</file>
+
+<file path=ppt/notesSlides/notesSlide8.xml><?xml version="1.0" encoding="utf-8"?>
+<p:notes xmlns:a="http://schemas.openxmlformats.org/drawingml/2006/main" xmlns:p="http://schemas.openxmlformats.org/presentationml/2006/main" xmlns:r="http://schemas.openxmlformats.org/officeDocument/2006/relationships">
+  <p:cSld>
+    <p:spTree>
+      <p:nvGrpSpPr>
+        <p:cNvPr id="1" name=""/>
+        <p:cNvGrpSpPr/>
+        <p:nvPr/>
+      </p:nvGrpSpPr>
+      <p:grpSpPr>
+        <a:xfrm>
+          <a:off x="0" y="0"/>
+          <a:ext cx="0" cy="0"/>
+          <a:chOff x="0" y="0"/>
+          <a:chExt cx="0" cy="0"/>
+        </a:xfrm>
+      </p:grpSpPr>
+      <p:sp>
+        <p:nvSpPr>
+          <p:cNvPr id="2" name="Slide Image Placeholder 1"/>
+          <p:cNvSpPr>
+            <a:spLocks noGrp="1"/>
+          </p:cNvSpPr>
+          <p:nvPr>
+            <p:ph type="sldImg" idx="2"/>
+          </p:nvPr>
+        </p:nvSpPr>
+        <p:spPr/>
+      </p:sp>
+      <p:sp>
+        <p:nvSpPr>
+          <p:cNvPr id="3" name="Notes Placeholder 2"/>
+          <p:cNvSpPr>
+            <a:spLocks noGrp="1"/>
+          </p:cNvSpPr>
+          <p:nvPr>
+            <p:ph type="body" idx="3" sz="quarter"/>
+          </p:nvPr>
+        </p:nvSpPr>
+        <p:spPr/>
+        <p:txBody>
+          <a:bodyPr/>
+          <a:lstStyle/>
+          <a:p>
+            <a:r>
+              <a:t>שאלה 6 מבקשת להציג את האירוע בכל דרך. בשקף הזה הצגנו: סרטון, תמונה, שיר קצר ושאלה לדיון.</a:t>
+            </a:r>
+          </a:p>
+          <a:p>
+            <a:r>
+              <a:t>השיר נכתב לשקף הזה, ואינו מבוסס על חומר מוגן זכויות. ניתן לשנות אותו לפי הרצון.</a:t>
             </a:r>
           </a:p>
         </p:txBody>
@@ -3814,7 +4037,7 @@
     <p:bg>
       <p:bgPr>
         <a:solidFill>
-          <a:srgbClr val="FFF8E7"/>
+          <a:srgbClr val="F4F4F4"/>
         </a:solidFill>
         <a:effectLst/>
       </p:bgPr>
@@ -3841,7 +4064,7 @@
             <a:avLst/>
           </a:prstGeom>
           <a:solidFill>
-            <a:srgbClr val="FF8C28"/>
+            <a:srgbClr val="E82127"/>
           </a:solidFill>
           <a:ln>
             <a:noFill/>
@@ -3877,7 +4100,7 @@
         </p:nvSpPr>
         <p:spPr>
           <a:xfrm>
-            <a:off x="731520" y="1463040"/>
+            <a:off x="731520" y="1371600"/>
             <a:ext cx="10728655" cy="1463040"/>
           </a:xfrm>
           <a:prstGeom prst="rect">
@@ -3899,7 +4122,7 @@
             <a:r>
               <a:rPr sz="5000" b="1" lang="he-IL" altLang="en-US">
                 <a:solidFill>
-                  <a:srgbClr val="1B3A6B"/>
+                  <a:srgbClr val="171A20"/>
                 </a:solidFill>
                 <a:latin typeface="Arial"/>
               </a:rPr>
@@ -3916,7 +4139,7 @@
         </p:nvSpPr>
         <p:spPr>
           <a:xfrm>
-            <a:off x="731520" y="2926080"/>
+            <a:off x="731520" y="2834640"/>
             <a:ext cx="10728655" cy="731520"/>
           </a:xfrm>
           <a:prstGeom prst="rect">
@@ -3938,11 +4161,11 @@
             <a:r>
               <a:rPr sz="3000" b="0" lang="he-IL" altLang="en-US">
                 <a:solidFill>
-                  <a:srgbClr val="1B3A6B"/>
+                  <a:srgbClr val="5C5E62"/>
                 </a:solidFill>
                 <a:latin typeface="Arial"/>
               </a:rPr>
-              <a:t>הדגמה מ-15 באוקטובר 2026</a:t>
+              <a:t>ההדגמה מ-15 באוקטובר 2026</a:t>
             </a:r>
           </a:p>
         </p:txBody>
@@ -3955,7 +4178,7 @@
         </p:nvSpPr>
         <p:spPr>
           <a:xfrm>
-            <a:off x="731520" y="3657600"/>
+            <a:off x="731520" y="3611880"/>
             <a:ext cx="10728655" cy="1097280"/>
           </a:xfrm>
           <a:prstGeom prst="rect">
@@ -3977,7 +4200,7 @@
             <a:r>
               <a:rPr sz="3000" b="1" lang="he-IL" altLang="en-US">
                 <a:solidFill>
-                  <a:srgbClr val="FF8C28"/>
+                  <a:srgbClr val="E82127"/>
                 </a:solidFill>
                 <a:latin typeface="Arial"/>
               </a:rPr>
@@ -4016,7 +4239,7 @@
             <a:r>
               <a:rPr sz="2000" b="0" lang="he-IL" altLang="en-US">
                 <a:solidFill>
-                  <a:srgbClr val="222233"/>
+                  <a:srgbClr val="171A20"/>
                 </a:solidFill>
                 <a:latin typeface="Arial"/>
               </a:rPr>
@@ -4039,7 +4262,7 @@
     <p:bg>
       <p:bgPr>
         <a:solidFill>
-          <a:srgbClr val="FFF8E7"/>
+          <a:srgbClr val="F4F4F4"/>
         </a:solidFill>
         <a:effectLst/>
       </p:bgPr>
@@ -4053,7 +4276,50 @@
       <p:grpSpPr/>
       <p:sp>
         <p:nvSpPr>
-          <p:cNvPr id="2" name="TextBox 1"/>
+          <p:cNvPr id="2" name="Rectangle 1"/>
+          <p:cNvSpPr/>
+          <p:nvPr/>
+        </p:nvSpPr>
+        <p:spPr>
+          <a:xfrm>
+            <a:off x="0" y="0"/>
+            <a:ext cx="12191695" cy="109728"/>
+          </a:xfrm>
+          <a:prstGeom prst="rect">
+            <a:avLst/>
+          </a:prstGeom>
+          <a:solidFill>
+            <a:srgbClr val="E82127"/>
+          </a:solidFill>
+          <a:ln>
+            <a:noFill/>
+          </a:ln>
+        </p:spPr>
+        <p:style>
+          <a:lnRef idx="1">
+            <a:schemeClr val="accent1"/>
+          </a:lnRef>
+          <a:fillRef idx="3">
+            <a:schemeClr val="accent1"/>
+          </a:fillRef>
+          <a:effectRef idx="2">
+            <a:schemeClr val="accent1"/>
+          </a:effectRef>
+          <a:fontRef idx="minor">
+            <a:schemeClr val="lt1"/>
+          </a:fontRef>
+        </p:style>
+        <p:txBody>
+          <a:bodyPr rtlCol="0" anchor="ctr"/>
+          <a:lstStyle/>
+          <a:p>
+            <a:pPr algn="ctr"/>
+          </a:p>
+        </p:txBody>
+      </p:sp>
+      <p:sp>
+        <p:nvSpPr>
+          <p:cNvPr id="3" name="TextBox 2"/>
           <p:cNvSpPr txBox="1"/>
           <p:nvPr/>
         </p:nvSpPr>
@@ -4081,18 +4347,18 @@
             <a:r>
               <a:rPr sz="4000" b="1" lang="he-IL" altLang="en-US">
                 <a:solidFill>
-                  <a:srgbClr val="1B3A6B"/>
+                  <a:srgbClr val="171A20"/>
                 </a:solidFill>
                 <a:latin typeface="Arial"/>
               </a:rPr>
-              <a:t>מה ראינו בהדגמה?</a:t>
-            </a:r>
-          </a:p>
-        </p:txBody>
-      </p:sp>
-      <p:sp>
-        <p:nvSpPr>
-          <p:cNvPr id="3" name="TextBox 2"/>
+              <a:t>מה קרה?</a:t>
+            </a:r>
+          </a:p>
+        </p:txBody>
+      </p:sp>
+      <p:sp>
+        <p:nvSpPr>
+          <p:cNvPr id="4" name="TextBox 3"/>
           <p:cNvSpPr txBox="1"/>
           <p:nvPr/>
         </p:nvSpPr>
@@ -4120,11 +4386,11 @@
             <a:r>
               <a:rPr sz="2600" b="0" lang="he-IL" altLang="en-US">
                 <a:solidFill>
-                  <a:srgbClr val="222233"/>
+                  <a:srgbClr val="171A20"/>
                 </a:solidFill>
                 <a:latin typeface="Arial"/>
               </a:rPr>
-              <a:t>הרכב נסע במעלה רמפה מעוגלת, עד שהתהפך עם הגג כלפי מטה.</a:t>
+              <a:t>טסלה חשפה את הדור החדש של הרודסטר, מכונית ספורט חשמלית.</a:t>
             </a:r>
           </a:p>
           <a:p>
@@ -4136,11 +4402,11 @@
             <a:r>
               <a:rPr sz="2600" b="0" lang="he-IL" altLang="en-US">
                 <a:solidFill>
-                  <a:srgbClr val="222233"/>
+                  <a:srgbClr val="171A20"/>
                 </a:solidFill>
                 <a:latin typeface="Arial"/>
               </a:rPr>
-              <a:t>אחר כך קפץ מקצה הרמפה, התהפך באוויר ונחת על הגלגלים.</a:t>
+              <a:t>הרכב נסע במעלה רמפה מעוגלת, התהפך עם הגג כלפי מטה, קפץ מקצה הרמפה והסתובב באוויר.</a:t>
             </a:r>
           </a:p>
           <a:p>
@@ -4152,27 +4418,11 @@
             <a:r>
               <a:rPr sz="2600" b="0" lang="he-IL" altLang="en-US">
                 <a:solidFill>
-                  <a:srgbClr val="222233"/>
+                  <a:srgbClr val="171A20"/>
                 </a:solidFill>
                 <a:latin typeface="Arial"/>
               </a:rPr>
-              <a:t>ההדגמה נעשתה ללא נהג, באתר הבדיקות של SpaceX בטקסס.</a:t>
-            </a:r>
-          </a:p>
-          <a:p>
-            <a:pPr algn="r" rtl="1">
-              <a:spcAft>
-                <a:spcPts val="1000"/>
-              </a:spcAft>
-            </a:pPr>
-            <a:r>
-              <a:rPr sz="2600" b="0" lang="he-IL" altLang="en-US">
-                <a:solidFill>
-                  <a:srgbClr val="222233"/>
-                </a:solidFill>
-                <a:latin typeface="Arial"/>
-              </a:rPr>
-              <a:t>מומחה שדיבר עם CNN אמר שזו יותר קפיצה מאשר טיסה מתמשכת.</a:t>
+              <a:t>הוא נחת על הגלגלים. לפי הדיווחים, זו הייתה קפיצה קצרה ולא טיסה ממושכת.</a:t>
             </a:r>
           </a:p>
         </p:txBody>
@@ -4191,7 +4441,7 @@
     <p:bg>
       <p:bgPr>
         <a:solidFill>
-          <a:srgbClr val="FFF8E7"/>
+          <a:srgbClr val="F4F4F4"/>
         </a:solidFill>
         <a:effectLst/>
       </p:bgPr>
@@ -4205,7 +4455,50 @@
       <p:grpSpPr/>
       <p:sp>
         <p:nvSpPr>
-          <p:cNvPr id="2" name="TextBox 1"/>
+          <p:cNvPr id="2" name="Rectangle 1"/>
+          <p:cNvSpPr/>
+          <p:nvPr/>
+        </p:nvSpPr>
+        <p:spPr>
+          <a:xfrm>
+            <a:off x="0" y="0"/>
+            <a:ext cx="12191695" cy="109728"/>
+          </a:xfrm>
+          <a:prstGeom prst="rect">
+            <a:avLst/>
+          </a:prstGeom>
+          <a:solidFill>
+            <a:srgbClr val="E82127"/>
+          </a:solidFill>
+          <a:ln>
+            <a:noFill/>
+          </a:ln>
+        </p:spPr>
+        <p:style>
+          <a:lnRef idx="1">
+            <a:schemeClr val="accent1"/>
+          </a:lnRef>
+          <a:fillRef idx="3">
+            <a:schemeClr val="accent1"/>
+          </a:fillRef>
+          <a:effectRef idx="2">
+            <a:schemeClr val="accent1"/>
+          </a:effectRef>
+          <a:fontRef idx="minor">
+            <a:schemeClr val="lt1"/>
+          </a:fontRef>
+        </p:style>
+        <p:txBody>
+          <a:bodyPr rtlCol="0" anchor="ctr"/>
+          <a:lstStyle/>
+          <a:p>
+            <a:pPr algn="ctr"/>
+          </a:p>
+        </p:txBody>
+      </p:sp>
+      <p:sp>
+        <p:nvSpPr>
+          <p:cNvPr id="3" name="TextBox 2"/>
           <p:cNvSpPr txBox="1"/>
           <p:nvPr/>
         </p:nvSpPr>
@@ -4233,25 +4526,25 @@
             <a:r>
               <a:rPr sz="4000" b="1" lang="he-IL" altLang="en-US">
                 <a:solidFill>
-                  <a:srgbClr val="1B3A6B"/>
+                  <a:srgbClr val="171A20"/>
                 </a:solidFill>
                 <a:latin typeface="Arial"/>
               </a:rPr>
-              <a:t>איך זה עובד?</a:t>
-            </a:r>
-          </a:p>
-        </p:txBody>
-      </p:sp>
-      <p:sp>
-        <p:nvSpPr>
-          <p:cNvPr id="3" name="Rounded Rectangle 2"/>
+              <a:t>מתי ואיפה?</a:t>
+            </a:r>
+          </a:p>
+        </p:txBody>
+      </p:sp>
+      <p:sp>
+        <p:nvSpPr>
+          <p:cNvPr id="4" name="Rounded Rectangle 3"/>
           <p:cNvSpPr/>
           <p:nvPr/>
         </p:nvSpPr>
         <p:spPr>
           <a:xfrm>
             <a:off x="548640" y="1554480"/>
-            <a:ext cx="4754880" cy="1188720"/>
+            <a:ext cx="5394960" cy="2103120"/>
           </a:xfrm>
           <a:prstGeom prst="roundRect">
             <a:avLst>
@@ -4259,7 +4552,7 @@
             </a:avLst>
           </a:prstGeom>
           <a:solidFill>
-            <a:srgbClr val="FF8C28"/>
+            <a:srgbClr val="E82127"/>
           </a:solidFill>
           <a:ln>
             <a:noFill/>
@@ -4280,7 +4573,7 @@
           </a:fontRef>
         </p:style>
         <p:txBody>
-          <a:bodyPr rtlCol="0" anchor="ctr" wrap="square" lIns="228600" rIns="228600"/>
+          <a:bodyPr rtlCol="0" anchor="ctr" wrap="square" lIns="1143000" rIns="228600"/>
           <a:lstStyle/>
           <a:p>
             <a:pPr algn="r" rtl="1"/>
@@ -4291,7 +4584,7 @@
                 </a:solidFill>
                 <a:latin typeface="Arial"/>
               </a:rPr>
-              <a:t>מאווררים מתחת לרכב</a:t>
+              <a:t>15 באוקטובר 2026</a:t>
             </a:r>
           </a:p>
           <a:p>
@@ -4303,21 +4596,107 @@
                 </a:solidFill>
                 <a:latin typeface="Arial"/>
               </a:rPr>
-              <a:t>יניקה שמחזיקה את הרכב על הרמפה, לפי טסלה</a:t>
-            </a:r>
-          </a:p>
-        </p:txBody>
-      </p:sp>
-      <p:sp>
-        <p:nvSpPr>
-          <p:cNvPr id="4" name="Rounded Rectangle 3"/>
+              <a:t>ההדגמה התקיימה ביום חמישי, אחרי דחייה מ-1 באוקטובר בגלל מזג אוויר</a:t>
+            </a:r>
+          </a:p>
+        </p:txBody>
+      </p:sp>
+      <p:sp>
+        <p:nvSpPr>
+          <p:cNvPr id="5" name="Oval 4"/>
           <p:cNvSpPr/>
           <p:nvPr/>
         </p:nvSpPr>
         <p:spPr>
           <a:xfrm>
-            <a:off x="548640" y="2926080"/>
-            <a:ext cx="4754880" cy="1188720"/>
+            <a:off x="822960" y="2286000"/>
+            <a:ext cx="640080" cy="640080"/>
+          </a:xfrm>
+          <a:prstGeom prst="ellipse">
+            <a:avLst/>
+          </a:prstGeom>
+          <a:solidFill>
+            <a:srgbClr val="FFFFFF"/>
+          </a:solidFill>
+          <a:ln>
+            <a:noFill/>
+          </a:ln>
+        </p:spPr>
+        <p:style>
+          <a:lnRef idx="1">
+            <a:schemeClr val="accent1"/>
+          </a:lnRef>
+          <a:fillRef idx="3">
+            <a:schemeClr val="accent1"/>
+          </a:fillRef>
+          <a:effectRef idx="2">
+            <a:schemeClr val="accent1"/>
+          </a:effectRef>
+          <a:fontRef idx="minor">
+            <a:schemeClr val="lt1"/>
+          </a:fontRef>
+        </p:style>
+        <p:txBody>
+          <a:bodyPr rtlCol="0" anchor="ctr"/>
+          <a:lstStyle/>
+          <a:p>
+            <a:pPr algn="ctr"/>
+          </a:p>
+        </p:txBody>
+      </p:sp>
+      <p:sp>
+        <p:nvSpPr>
+          <p:cNvPr id="6" name="Folded Corner 5"/>
+          <p:cNvSpPr/>
+          <p:nvPr/>
+        </p:nvSpPr>
+        <p:spPr>
+          <a:xfrm>
+            <a:off x="966978" y="2430018"/>
+            <a:ext cx="352044" cy="352044"/>
+          </a:xfrm>
+          <a:prstGeom prst="foldedCorner">
+            <a:avLst/>
+          </a:prstGeom>
+          <a:solidFill>
+            <a:srgbClr val="E82127"/>
+          </a:solidFill>
+          <a:ln>
+            <a:noFill/>
+          </a:ln>
+        </p:spPr>
+        <p:style>
+          <a:lnRef idx="1">
+            <a:schemeClr val="accent1"/>
+          </a:lnRef>
+          <a:fillRef idx="3">
+            <a:schemeClr val="accent1"/>
+          </a:fillRef>
+          <a:effectRef idx="2">
+            <a:schemeClr val="accent1"/>
+          </a:effectRef>
+          <a:fontRef idx="minor">
+            <a:schemeClr val="lt1"/>
+          </a:fontRef>
+        </p:style>
+        <p:txBody>
+          <a:bodyPr rtlCol="0" anchor="ctr"/>
+          <a:lstStyle/>
+          <a:p>
+            <a:pPr algn="ctr"/>
+          </a:p>
+        </p:txBody>
+      </p:sp>
+      <p:sp>
+        <p:nvSpPr>
+          <p:cNvPr id="7" name="Rounded Rectangle 6"/>
+          <p:cNvSpPr/>
+          <p:nvPr/>
+        </p:nvSpPr>
+        <p:spPr>
+          <a:xfrm>
+            <a:off x="6217920" y="1554480"/>
+            <a:ext cx="5394960" cy="2103120"/>
           </a:xfrm>
           <a:prstGeom prst="roundRect">
             <a:avLst>
@@ -4325,7 +4704,7 @@
             </a:avLst>
           </a:prstGeom>
           <a:solidFill>
-            <a:srgbClr val="3BA55D"/>
+            <a:srgbClr val="171A20"/>
           </a:solidFill>
           <a:ln>
             <a:noFill/>
@@ -4346,7 +4725,7 @@
           </a:fontRef>
         </p:style>
         <p:txBody>
-          <a:bodyPr rtlCol="0" anchor="ctr" wrap="square" lIns="228600" rIns="228600"/>
+          <a:bodyPr rtlCol="0" anchor="ctr" wrap="square" lIns="1143000" rIns="228600"/>
           <a:lstStyle/>
           <a:p>
             <a:pPr algn="r" rtl="1"/>
@@ -4357,7 +4736,7 @@
                 </a:solidFill>
                 <a:latin typeface="Arial"/>
               </a:rPr>
-              <a:t>סילוני גז קרים</a:t>
+              <a:t>מקגרגור, טקסס</a:t>
             </a:r>
           </a:p>
           <a:p>
@@ -4369,21 +4748,254 @@
                 </a:solidFill>
                 <a:latin typeface="Arial"/>
               </a:rPr>
-              <a:t>דחיפה קטנה שעוזרת לקפוץ ולהסתובב, בשיתוף SpaceX</a:t>
-            </a:r>
-          </a:p>
-        </p:txBody>
-      </p:sp>
-      <p:sp>
-        <p:nvSpPr>
-          <p:cNvPr id="5" name="Rounded Rectangle 4"/>
+              <a:t>במתקן הבדיקות של SpaceX, חברה שמאסק מנהל גם היא</a:t>
+            </a:r>
+          </a:p>
+        </p:txBody>
+      </p:sp>
+      <p:sp>
+        <p:nvSpPr>
+          <p:cNvPr id="8" name="Oval 7"/>
           <p:cNvSpPr/>
           <p:nvPr/>
         </p:nvSpPr>
         <p:spPr>
           <a:xfrm>
-            <a:off x="548640" y="4297680"/>
-            <a:ext cx="4754880" cy="1188720"/>
+            <a:off x="6492240" y="2286000"/>
+            <a:ext cx="640080" cy="640080"/>
+          </a:xfrm>
+          <a:prstGeom prst="ellipse">
+            <a:avLst/>
+          </a:prstGeom>
+          <a:solidFill>
+            <a:srgbClr val="FFFFFF"/>
+          </a:solidFill>
+          <a:ln>
+            <a:noFill/>
+          </a:ln>
+        </p:spPr>
+        <p:style>
+          <a:lnRef idx="1">
+            <a:schemeClr val="accent1"/>
+          </a:lnRef>
+          <a:fillRef idx="3">
+            <a:schemeClr val="accent1"/>
+          </a:fillRef>
+          <a:effectRef idx="2">
+            <a:schemeClr val="accent1"/>
+          </a:effectRef>
+          <a:fontRef idx="minor">
+            <a:schemeClr val="lt1"/>
+          </a:fontRef>
+        </p:style>
+        <p:txBody>
+          <a:bodyPr rtlCol="0" anchor="ctr"/>
+          <a:lstStyle/>
+          <a:p>
+            <a:pPr algn="ctr"/>
+          </a:p>
+        </p:txBody>
+      </p:sp>
+      <p:sp>
+        <p:nvSpPr>
+          <p:cNvPr id="9" name="Teardrop 8"/>
+          <p:cNvSpPr/>
+          <p:nvPr/>
+        </p:nvSpPr>
+        <p:spPr>
+          <a:xfrm>
+            <a:off x="6636258" y="2430018"/>
+            <a:ext cx="352044" cy="352044"/>
+          </a:xfrm>
+          <a:prstGeom prst="teardrop">
+            <a:avLst/>
+          </a:prstGeom>
+          <a:solidFill>
+            <a:srgbClr val="171A20"/>
+          </a:solidFill>
+          <a:ln>
+            <a:noFill/>
+          </a:ln>
+        </p:spPr>
+        <p:style>
+          <a:lnRef idx="1">
+            <a:schemeClr val="accent1"/>
+          </a:lnRef>
+          <a:fillRef idx="3">
+            <a:schemeClr val="accent1"/>
+          </a:fillRef>
+          <a:effectRef idx="2">
+            <a:schemeClr val="accent1"/>
+          </a:effectRef>
+          <a:fontRef idx="minor">
+            <a:schemeClr val="lt1"/>
+          </a:fontRef>
+        </p:style>
+        <p:txBody>
+          <a:bodyPr rtlCol="0" anchor="ctr"/>
+          <a:lstStyle/>
+          <a:p>
+            <a:pPr algn="ctr"/>
+          </a:p>
+        </p:txBody>
+      </p:sp>
+      <p:sp>
+        <p:nvSpPr>
+          <p:cNvPr id="10" name="TextBox 9"/>
+          <p:cNvSpPr txBox="1"/>
+          <p:nvPr/>
+        </p:nvSpPr>
+        <p:spPr>
+          <a:xfrm>
+            <a:off x="731520" y="4114800"/>
+            <a:ext cx="10698480" cy="2011680"/>
+          </a:xfrm>
+          <a:prstGeom prst="rect">
+            <a:avLst/>
+          </a:prstGeom>
+          <a:noFill/>
+        </p:spPr>
+        <p:txBody>
+          <a:bodyPr wrap="square" anchor="t">
+            <a:spAutoFit/>
+          </a:bodyPr>
+          <a:lstStyle/>
+          <a:p>
+            <a:pPr algn="r" rtl="1">
+              <a:spcAft>
+                <a:spcPts val="1000"/>
+              </a:spcAft>
+            </a:pPr>
+            <a:r>
+              <a:rPr sz="2200" b="0" lang="he-IL" altLang="en-US">
+                <a:solidFill>
+                  <a:srgbClr val="5C5E62"/>
+                </a:solidFill>
+                <a:latin typeface="Arial"/>
+              </a:rPr>
+              <a:t>שימו לב: המועד והמיקום מבוססים על דיווחי חדשות. לפני ההצגה, בדקו את הפרטים בכתבה המקורית.</a:t>
+            </a:r>
+          </a:p>
+        </p:txBody>
+      </p:sp>
+    </p:spTree>
+  </p:cSld>
+  <p:clrMapOvr>
+    <a:masterClrMapping/>
+  </p:clrMapOvr>
+</p:sld>
+</file>
+
+<file path=ppt/slides/slide4.xml><?xml version="1.0" encoding="utf-8"?>
+<p:sld xmlns:a="http://schemas.openxmlformats.org/drawingml/2006/main" xmlns:p="http://schemas.openxmlformats.org/presentationml/2006/main" xmlns:r="http://schemas.openxmlformats.org/officeDocument/2006/relationships">
+  <p:cSld>
+    <p:bg>
+      <p:bgPr>
+        <a:solidFill>
+          <a:srgbClr val="F4F4F4"/>
+        </a:solidFill>
+        <a:effectLst/>
+      </p:bgPr>
+    </p:bg>
+    <p:spTree>
+      <p:nvGrpSpPr>
+        <p:cNvPr id="1" name=""/>
+        <p:cNvGrpSpPr/>
+        <p:nvPr/>
+      </p:nvGrpSpPr>
+      <p:grpSpPr/>
+      <p:sp>
+        <p:nvSpPr>
+          <p:cNvPr id="2" name="Rectangle 1"/>
+          <p:cNvSpPr/>
+          <p:nvPr/>
+        </p:nvSpPr>
+        <p:spPr>
+          <a:xfrm>
+            <a:off x="0" y="0"/>
+            <a:ext cx="12191695" cy="109728"/>
+          </a:xfrm>
+          <a:prstGeom prst="rect">
+            <a:avLst/>
+          </a:prstGeom>
+          <a:solidFill>
+            <a:srgbClr val="E82127"/>
+          </a:solidFill>
+          <a:ln>
+            <a:noFill/>
+          </a:ln>
+        </p:spPr>
+        <p:style>
+          <a:lnRef idx="1">
+            <a:schemeClr val="accent1"/>
+          </a:lnRef>
+          <a:fillRef idx="3">
+            <a:schemeClr val="accent1"/>
+          </a:fillRef>
+          <a:effectRef idx="2">
+            <a:schemeClr val="accent1"/>
+          </a:effectRef>
+          <a:fontRef idx="minor">
+            <a:schemeClr val="lt1"/>
+          </a:fontRef>
+        </p:style>
+        <p:txBody>
+          <a:bodyPr rtlCol="0" anchor="ctr"/>
+          <a:lstStyle/>
+          <a:p>
+            <a:pPr algn="ctr"/>
+          </a:p>
+        </p:txBody>
+      </p:sp>
+      <p:sp>
+        <p:nvSpPr>
+          <p:cNvPr id="3" name="TextBox 2"/>
+          <p:cNvSpPr txBox="1"/>
+          <p:nvPr/>
+        </p:nvSpPr>
+        <p:spPr>
+          <a:xfrm>
+            <a:off x="548640" y="320040"/>
+            <a:ext cx="11094415" cy="914400"/>
+          </a:xfrm>
+          <a:prstGeom prst="rect">
+            <a:avLst/>
+          </a:prstGeom>
+          <a:noFill/>
+        </p:spPr>
+        <p:txBody>
+          <a:bodyPr wrap="square" anchor="t">
+            <a:spAutoFit/>
+          </a:bodyPr>
+          <a:lstStyle/>
+          <a:p>
+            <a:pPr algn="r" rtl="1">
+              <a:spcAft>
+                <a:spcPts val="1000"/>
+              </a:spcAft>
+            </a:pPr>
+            <a:r>
+              <a:rPr sz="4000" b="1" lang="he-IL" altLang="en-US">
+                <a:solidFill>
+                  <a:srgbClr val="171A20"/>
+                </a:solidFill>
+                <a:latin typeface="Arial"/>
+              </a:rPr>
+              <a:t>מי מעורב?</a:t>
+            </a:r>
+          </a:p>
+        </p:txBody>
+      </p:sp>
+      <p:sp>
+        <p:nvSpPr>
+          <p:cNvPr id="4" name="Rounded Rectangle 3"/>
+          <p:cNvSpPr/>
+          <p:nvPr/>
+        </p:nvSpPr>
+        <p:spPr>
+          <a:xfrm>
+            <a:off x="548640" y="1554480"/>
+            <a:ext cx="3566160" cy="2194560"/>
           </a:xfrm>
           <a:prstGeom prst="roundRect">
             <a:avLst>
@@ -4391,7 +5003,7 @@
             </a:avLst>
           </a:prstGeom>
           <a:solidFill>
-            <a:srgbClr val="E85D9B"/>
+            <a:srgbClr val="E82127"/>
           </a:solidFill>
           <a:ln>
             <a:noFill/>
@@ -4423,7 +5035,7 @@
                 </a:solidFill>
                 <a:latin typeface="Arial"/>
               </a:rPr>
-              <a:t>עדיין לא מפורט</a:t>
+              <a:t>טסלה</a:t>
             </a:r>
           </a:p>
           <a:p>
@@ -4435,14 +5047,545 @@
                 </a:solidFill>
                 <a:latin typeface="Arial"/>
               </a:rPr>
-              <a:t>מספר הסילונים ומיקומם מדווחים שונה בין מקורות</a:t>
+              <a:t>יצרנית הרכב. הרודסטר הוא רכב ספורט חשמלי שלה</a:t>
+            </a:r>
+          </a:p>
+        </p:txBody>
+      </p:sp>
+      <p:sp>
+        <p:nvSpPr>
+          <p:cNvPr id="5" name="Rounded Rectangle 4"/>
+          <p:cNvSpPr/>
+          <p:nvPr/>
+        </p:nvSpPr>
+        <p:spPr>
+          <a:xfrm>
+            <a:off x="4297680" y="1554480"/>
+            <a:ext cx="3566160" cy="2194560"/>
+          </a:xfrm>
+          <a:prstGeom prst="roundRect">
+            <a:avLst>
+              <a:gd name="adj" fmla="val 12000"/>
+            </a:avLst>
+          </a:prstGeom>
+          <a:solidFill>
+            <a:srgbClr val="171A20"/>
+          </a:solidFill>
+          <a:ln>
+            <a:noFill/>
+          </a:ln>
+        </p:spPr>
+        <p:style>
+          <a:lnRef idx="1">
+            <a:schemeClr val="accent1"/>
+          </a:lnRef>
+          <a:fillRef idx="3">
+            <a:schemeClr val="accent1"/>
+          </a:fillRef>
+          <a:effectRef idx="2">
+            <a:schemeClr val="accent1"/>
+          </a:effectRef>
+          <a:fontRef idx="minor">
+            <a:schemeClr val="lt1"/>
+          </a:fontRef>
+        </p:style>
+        <p:txBody>
+          <a:bodyPr rtlCol="0" anchor="ctr" wrap="square" lIns="228600" rIns="228600"/>
+          <a:lstStyle/>
+          <a:p>
+            <a:pPr algn="r" rtl="1"/>
+            <a:r>
+              <a:rPr sz="2600" b="1" lang="he-IL" altLang="en-US">
+                <a:solidFill>
+                  <a:srgbClr val="FFFFFF"/>
+                </a:solidFill>
+                <a:latin typeface="Arial"/>
+              </a:rPr>
+              <a:t>SpaceX</a:t>
+            </a:r>
+          </a:p>
+          <a:p>
+            <a:pPr algn="r" rtl="1"/>
+            <a:r>
+              <a:rPr sz="2000" b="0" lang="he-IL" altLang="en-US">
+                <a:solidFill>
+                  <a:srgbClr val="FFFFFF"/>
+                </a:solidFill>
+                <a:latin typeface="Arial"/>
+              </a:rPr>
+              <a:t>פיתחה יחד עם טסלה את סילוני הגז הקרים לדחף</a:t>
+            </a:r>
+          </a:p>
+        </p:txBody>
+      </p:sp>
+      <p:sp>
+        <p:nvSpPr>
+          <p:cNvPr id="6" name="Rounded Rectangle 5"/>
+          <p:cNvSpPr/>
+          <p:nvPr/>
+        </p:nvSpPr>
+        <p:spPr>
+          <a:xfrm>
+            <a:off x="8046720" y="1554480"/>
+            <a:ext cx="3566160" cy="2194560"/>
+          </a:xfrm>
+          <a:prstGeom prst="roundRect">
+            <a:avLst>
+              <a:gd name="adj" fmla="val 12000"/>
+            </a:avLst>
+          </a:prstGeom>
+          <a:solidFill>
+            <a:srgbClr val="5C5E62"/>
+          </a:solidFill>
+          <a:ln>
+            <a:noFill/>
+          </a:ln>
+        </p:spPr>
+        <p:style>
+          <a:lnRef idx="1">
+            <a:schemeClr val="accent1"/>
+          </a:lnRef>
+          <a:fillRef idx="3">
+            <a:schemeClr val="accent1"/>
+          </a:fillRef>
+          <a:effectRef idx="2">
+            <a:schemeClr val="accent1"/>
+          </a:effectRef>
+          <a:fontRef idx="minor">
+            <a:schemeClr val="lt1"/>
+          </a:fontRef>
+        </p:style>
+        <p:txBody>
+          <a:bodyPr rtlCol="0" anchor="ctr" wrap="square" lIns="228600" rIns="228600"/>
+          <a:lstStyle/>
+          <a:p>
+            <a:pPr algn="r" rtl="1"/>
+            <a:r>
+              <a:rPr sz="2600" b="1" lang="he-IL" altLang="en-US">
+                <a:solidFill>
+                  <a:srgbClr val="FFFFFF"/>
+                </a:solidFill>
+                <a:latin typeface="Arial"/>
+              </a:rPr>
+              <a:t>אילון מאסק</a:t>
+            </a:r>
+          </a:p>
+          <a:p>
+            <a:pPr algn="r" rtl="1"/>
+            <a:r>
+              <a:rPr sz="2000" b="0" lang="he-IL" altLang="en-US">
+                <a:solidFill>
+                  <a:srgbClr val="FFFFFF"/>
+                </a:solidFill>
+                <a:latin typeface="Arial"/>
+              </a:rPr>
+              <a:t>מוביל את טסלה ואת SpaceX לפי הדיווחים. אנשים רבים רואים בו מוביל חדשנות</a:t>
+            </a:r>
+          </a:p>
+        </p:txBody>
+      </p:sp>
+      <p:sp>
+        <p:nvSpPr>
+          <p:cNvPr id="7" name="Rectangle 6"/>
+          <p:cNvSpPr/>
+          <p:nvPr/>
+        </p:nvSpPr>
+        <p:spPr>
+          <a:xfrm>
+            <a:off x="548640" y="4023360"/>
+            <a:ext cx="2926080" cy="2377440"/>
+          </a:xfrm>
+          <a:prstGeom prst="rect">
+            <a:avLst/>
+          </a:prstGeom>
+          <a:solidFill>
+            <a:srgbClr val="FFFFFF"/>
+          </a:solidFill>
+          <a:ln>
+            <a:solidFill>
+              <a:srgbClr val="5C5E62"/>
+            </a:solidFill>
+          </a:ln>
+        </p:spPr>
+        <p:style>
+          <a:lnRef idx="1">
+            <a:schemeClr val="accent1"/>
+          </a:lnRef>
+          <a:fillRef idx="3">
+            <a:schemeClr val="accent1"/>
+          </a:fillRef>
+          <a:effectRef idx="2">
+            <a:schemeClr val="accent1"/>
+          </a:effectRef>
+          <a:fontRef idx="minor">
+            <a:schemeClr val="lt1"/>
+          </a:fontRef>
+        </p:style>
+        <p:txBody>
+          <a:bodyPr rtlCol="0" anchor="ctr" wrap="square"/>
+          <a:lstStyle/>
+          <a:p>
+            <a:pPr algn="r" rtl="1"/>
+            <a:r>
+              <a:rPr sz="1600" b="0" lang="he-IL" altLang="en-US">
+                <a:solidFill>
+                  <a:srgbClr val="5C5E62"/>
+                </a:solidFill>
+                <a:latin typeface="Arial"/>
+              </a:rPr>
+              <a:t>כאן תוצב תמונה של אילון מאסק מרישיון פתוח, עם קרדיט</a:t>
+            </a:r>
+          </a:p>
+        </p:txBody>
+      </p:sp>
+      <p:sp>
+        <p:nvSpPr>
+          <p:cNvPr id="8" name="TextBox 7"/>
+          <p:cNvSpPr txBox="1"/>
+          <p:nvPr/>
+        </p:nvSpPr>
+        <p:spPr>
+          <a:xfrm>
+            <a:off x="3840480" y="4114800"/>
+            <a:ext cx="7772400" cy="2194560"/>
+          </a:xfrm>
+          <a:prstGeom prst="rect">
+            <a:avLst/>
+          </a:prstGeom>
+          <a:noFill/>
+        </p:spPr>
+        <p:txBody>
+          <a:bodyPr wrap="square" anchor="t">
+            <a:spAutoFit/>
+          </a:bodyPr>
+          <a:lstStyle/>
+          <a:p>
+            <a:pPr algn="r" rtl="1">
+              <a:spcAft>
+                <a:spcPts val="1000"/>
+              </a:spcAft>
+            </a:pPr>
+            <a:r>
+              <a:rPr sz="2400" b="0" lang="he-IL" altLang="en-US">
+                <a:solidFill>
+                  <a:srgbClr val="171A20"/>
+                </a:solidFill>
+                <a:latin typeface="Arial"/>
+              </a:rPr>
+              <a:t>מאסק הוא הדמות המרכזית בטסלה וב-SpaceX, ומכאן הקשר בין שתי החברות בהדגמה.</a:t>
+            </a:r>
+          </a:p>
+        </p:txBody>
+      </p:sp>
+    </p:spTree>
+  </p:cSld>
+  <p:clrMapOvr>
+    <a:masterClrMapping/>
+  </p:clrMapOvr>
+</p:sld>
+</file>
+
+<file path=ppt/slides/slide5.xml><?xml version="1.0" encoding="utf-8"?>
+<p:sld xmlns:a="http://schemas.openxmlformats.org/drawingml/2006/main" xmlns:p="http://schemas.openxmlformats.org/presentationml/2006/main" xmlns:r="http://schemas.openxmlformats.org/officeDocument/2006/relationships">
+  <p:cSld>
+    <p:bg>
+      <p:bgPr>
+        <a:solidFill>
+          <a:srgbClr val="F4F4F4"/>
+        </a:solidFill>
+        <a:effectLst/>
+      </p:bgPr>
+    </p:bg>
+    <p:spTree>
+      <p:nvGrpSpPr>
+        <p:cNvPr id="1" name=""/>
+        <p:cNvGrpSpPr/>
+        <p:nvPr/>
+      </p:nvGrpSpPr>
+      <p:grpSpPr/>
+      <p:sp>
+        <p:nvSpPr>
+          <p:cNvPr id="2" name="Rectangle 1"/>
+          <p:cNvSpPr/>
+          <p:nvPr/>
+        </p:nvSpPr>
+        <p:spPr>
+          <a:xfrm>
+            <a:off x="0" y="0"/>
+            <a:ext cx="12191695" cy="109728"/>
+          </a:xfrm>
+          <a:prstGeom prst="rect">
+            <a:avLst/>
+          </a:prstGeom>
+          <a:solidFill>
+            <a:srgbClr val="E82127"/>
+          </a:solidFill>
+          <a:ln>
+            <a:noFill/>
+          </a:ln>
+        </p:spPr>
+        <p:style>
+          <a:lnRef idx="1">
+            <a:schemeClr val="accent1"/>
+          </a:lnRef>
+          <a:fillRef idx="3">
+            <a:schemeClr val="accent1"/>
+          </a:fillRef>
+          <a:effectRef idx="2">
+            <a:schemeClr val="accent1"/>
+          </a:effectRef>
+          <a:fontRef idx="minor">
+            <a:schemeClr val="lt1"/>
+          </a:fontRef>
+        </p:style>
+        <p:txBody>
+          <a:bodyPr rtlCol="0" anchor="ctr"/>
+          <a:lstStyle/>
+          <a:p>
+            <a:pPr algn="ctr"/>
+          </a:p>
+        </p:txBody>
+      </p:sp>
+      <p:sp>
+        <p:nvSpPr>
+          <p:cNvPr id="3" name="TextBox 2"/>
+          <p:cNvSpPr txBox="1"/>
+          <p:nvPr/>
+        </p:nvSpPr>
+        <p:spPr>
+          <a:xfrm>
+            <a:off x="548640" y="320040"/>
+            <a:ext cx="11094415" cy="914400"/>
+          </a:xfrm>
+          <a:prstGeom prst="rect">
+            <a:avLst/>
+          </a:prstGeom>
+          <a:noFill/>
+        </p:spPr>
+        <p:txBody>
+          <a:bodyPr wrap="square" anchor="t">
+            <a:spAutoFit/>
+          </a:bodyPr>
+          <a:lstStyle/>
+          <a:p>
+            <a:pPr algn="r" rtl="1">
+              <a:spcAft>
+                <a:spcPts val="1000"/>
+              </a:spcAft>
+            </a:pPr>
+            <a:r>
+              <a:rPr sz="4000" b="1" lang="he-IL" altLang="en-US">
+                <a:solidFill>
+                  <a:srgbClr val="171A20"/>
+                </a:solidFill>
+                <a:latin typeface="Arial"/>
+              </a:rPr>
+              <a:t>איך זה עובד?</a:t>
+            </a:r>
+          </a:p>
+        </p:txBody>
+      </p:sp>
+      <p:sp>
+        <p:nvSpPr>
+          <p:cNvPr id="4" name="Rounded Rectangle 3"/>
+          <p:cNvSpPr/>
+          <p:nvPr/>
+        </p:nvSpPr>
+        <p:spPr>
+          <a:xfrm>
+            <a:off x="548640" y="1554480"/>
+            <a:ext cx="4754880" cy="1188720"/>
+          </a:xfrm>
+          <a:prstGeom prst="roundRect">
+            <a:avLst>
+              <a:gd name="adj" fmla="val 12000"/>
+            </a:avLst>
+          </a:prstGeom>
+          <a:solidFill>
+            <a:srgbClr val="E82127"/>
+          </a:solidFill>
+          <a:ln>
+            <a:noFill/>
+          </a:ln>
+        </p:spPr>
+        <p:style>
+          <a:lnRef idx="1">
+            <a:schemeClr val="accent1"/>
+          </a:lnRef>
+          <a:fillRef idx="3">
+            <a:schemeClr val="accent1"/>
+          </a:fillRef>
+          <a:effectRef idx="2">
+            <a:schemeClr val="accent1"/>
+          </a:effectRef>
+          <a:fontRef idx="minor">
+            <a:schemeClr val="lt1"/>
+          </a:fontRef>
+        </p:style>
+        <p:txBody>
+          <a:bodyPr rtlCol="0" anchor="ctr" wrap="square" lIns="228600" rIns="228600"/>
+          <a:lstStyle/>
+          <a:p>
+            <a:pPr algn="r" rtl="1"/>
+            <a:r>
+              <a:rPr sz="2600" b="1" lang="he-IL" altLang="en-US">
+                <a:solidFill>
+                  <a:srgbClr val="FFFFFF"/>
+                </a:solidFill>
+                <a:latin typeface="Arial"/>
+              </a:rPr>
+              <a:t>מאווררים מתחת לרכב</a:t>
+            </a:r>
+          </a:p>
+          <a:p>
+            <a:pPr algn="r" rtl="1"/>
+            <a:r>
+              <a:rPr sz="2000" b="0" lang="he-IL" altLang="en-US">
+                <a:solidFill>
+                  <a:srgbClr val="FFFFFF"/>
+                </a:solidFill>
+                <a:latin typeface="Arial"/>
+              </a:rPr>
+              <a:t>יניקה שמחזיקה את הרכב על הרמפה, לפי טסלה</a:t>
+            </a:r>
+          </a:p>
+        </p:txBody>
+      </p:sp>
+      <p:sp>
+        <p:nvSpPr>
+          <p:cNvPr id="5" name="Rounded Rectangle 4"/>
+          <p:cNvSpPr/>
+          <p:nvPr/>
+        </p:nvSpPr>
+        <p:spPr>
+          <a:xfrm>
+            <a:off x="548640" y="2926080"/>
+            <a:ext cx="4754880" cy="1188720"/>
+          </a:xfrm>
+          <a:prstGeom prst="roundRect">
+            <a:avLst>
+              <a:gd name="adj" fmla="val 12000"/>
+            </a:avLst>
+          </a:prstGeom>
+          <a:solidFill>
+            <a:srgbClr val="171A20"/>
+          </a:solidFill>
+          <a:ln>
+            <a:noFill/>
+          </a:ln>
+        </p:spPr>
+        <p:style>
+          <a:lnRef idx="1">
+            <a:schemeClr val="accent1"/>
+          </a:lnRef>
+          <a:fillRef idx="3">
+            <a:schemeClr val="accent1"/>
+          </a:fillRef>
+          <a:effectRef idx="2">
+            <a:schemeClr val="accent1"/>
+          </a:effectRef>
+          <a:fontRef idx="minor">
+            <a:schemeClr val="lt1"/>
+          </a:fontRef>
+        </p:style>
+        <p:txBody>
+          <a:bodyPr rtlCol="0" anchor="ctr" wrap="square" lIns="228600" rIns="228600"/>
+          <a:lstStyle/>
+          <a:p>
+            <a:pPr algn="r" rtl="1"/>
+            <a:r>
+              <a:rPr sz="2600" b="1" lang="he-IL" altLang="en-US">
+                <a:solidFill>
+                  <a:srgbClr val="FFFFFF"/>
+                </a:solidFill>
+                <a:latin typeface="Arial"/>
+              </a:rPr>
+              <a:t>סילוני גז קרים</a:t>
+            </a:r>
+          </a:p>
+          <a:p>
+            <a:pPr algn="r" rtl="1"/>
+            <a:r>
+              <a:rPr sz="2000" b="0" lang="he-IL" altLang="en-US">
+                <a:solidFill>
+                  <a:srgbClr val="FFFFFF"/>
+                </a:solidFill>
+                <a:latin typeface="Arial"/>
+              </a:rPr>
+              <a:t>דחיפה קטנה שעוזרת לקפוץ ולהסתובב</a:t>
+            </a:r>
+          </a:p>
+        </p:txBody>
+      </p:sp>
+      <p:sp>
+        <p:nvSpPr>
+          <p:cNvPr id="6" name="Rounded Rectangle 5"/>
+          <p:cNvSpPr/>
+          <p:nvPr/>
+        </p:nvSpPr>
+        <p:spPr>
+          <a:xfrm>
+            <a:off x="548640" y="4297680"/>
+            <a:ext cx="4754880" cy="1188720"/>
+          </a:xfrm>
+          <a:prstGeom prst="roundRect">
+            <a:avLst>
+              <a:gd name="adj" fmla="val 12000"/>
+            </a:avLst>
+          </a:prstGeom>
+          <a:solidFill>
+            <a:srgbClr val="5C5E62"/>
+          </a:solidFill>
+          <a:ln>
+            <a:noFill/>
+          </a:ln>
+        </p:spPr>
+        <p:style>
+          <a:lnRef idx="1">
+            <a:schemeClr val="accent1"/>
+          </a:lnRef>
+          <a:fillRef idx="3">
+            <a:schemeClr val="accent1"/>
+          </a:fillRef>
+          <a:effectRef idx="2">
+            <a:schemeClr val="accent1"/>
+          </a:effectRef>
+          <a:fontRef idx="minor">
+            <a:schemeClr val="lt1"/>
+          </a:fontRef>
+        </p:style>
+        <p:txBody>
+          <a:bodyPr rtlCol="0" anchor="ctr" wrap="square" lIns="228600" rIns="228600"/>
+          <a:lstStyle/>
+          <a:p>
+            <a:pPr algn="r" rtl="1"/>
+            <a:r>
+              <a:rPr sz="2600" b="1" lang="he-IL" altLang="en-US">
+                <a:solidFill>
+                  <a:srgbClr val="FFFFFF"/>
+                </a:solidFill>
+                <a:latin typeface="Arial"/>
+              </a:rPr>
+              <a:t>עדיין לא מפורט</a:t>
+            </a:r>
+          </a:p>
+          <a:p>
+            <a:pPr algn="r" rtl="1"/>
+            <a:r>
+              <a:rPr sz="2000" b="0" lang="he-IL" altLang="en-US">
+                <a:solidFill>
+                  <a:srgbClr val="FFFFFF"/>
+                </a:solidFill>
+                <a:latin typeface="Arial"/>
+              </a:rPr>
+              <a:t>מספר הסילונים מדווח שונה בין מקורות</a:t>
             </a:r>
           </a:p>
         </p:txBody>
       </p:sp>
       <p:pic>
         <p:nvPicPr>
-          <p:cNvPr id="6" name="roadster-demo-animation.mp4">
+          <p:cNvPr id="7" name="roadster-demo-animation.mp4">
             <a:hlinkClick r:id="" action="ppaction://media"/>
           </p:cNvPr>
           <p:cNvPicPr>
@@ -4475,7 +5618,7 @@
       </p:pic>
       <p:sp>
         <p:nvSpPr>
-          <p:cNvPr id="7" name="TextBox 6"/>
+          <p:cNvPr id="8" name="TextBox 7"/>
           <p:cNvSpPr txBox="1"/>
           <p:nvPr/>
         </p:nvSpPr>
@@ -4503,7 +5646,7 @@
             <a:r>
               <a:rPr sz="1800" b="0" lang="he-IL" altLang="en-US">
                 <a:solidFill>
-                  <a:srgbClr val="222233"/>
+                  <a:srgbClr val="5C5E62"/>
                 </a:solidFill>
                 <a:latin typeface="Arial"/>
               </a:rPr>
@@ -4530,7 +5673,7 @@
                   </p:stCondLst>
                 </p:cTn>
                 <p:tgtEl>
-                  <p:spTgt spid="6"/>
+                  <p:spTgt spid="7"/>
                 </p:tgtEl>
               </p:cMediaNode>
             </p:video>
@@ -4542,13 +5685,13 @@
 </p:sld>
 </file>
 
-<file path=ppt/slides/slide4.xml><?xml version="1.0" encoding="utf-8"?>
+<file path=ppt/slides/slide6.xml><?xml version="1.0" encoding="utf-8"?>
 <p:sld xmlns:a="http://schemas.openxmlformats.org/drawingml/2006/main" xmlns:p="http://schemas.openxmlformats.org/presentationml/2006/main" xmlns:r="http://schemas.openxmlformats.org/officeDocument/2006/relationships">
   <p:cSld>
     <p:bg>
       <p:bgPr>
         <a:solidFill>
-          <a:srgbClr val="FFF8E7"/>
+          <a:srgbClr val="F4F4F4"/>
         </a:solidFill>
         <a:effectLst/>
       </p:bgPr>
@@ -4562,7 +5705,50 @@
       <p:grpSpPr/>
       <p:sp>
         <p:nvSpPr>
-          <p:cNvPr id="2" name="TextBox 1"/>
+          <p:cNvPr id="2" name="Rectangle 1"/>
+          <p:cNvSpPr/>
+          <p:nvPr/>
+        </p:nvSpPr>
+        <p:spPr>
+          <a:xfrm>
+            <a:off x="0" y="0"/>
+            <a:ext cx="12191695" cy="109728"/>
+          </a:xfrm>
+          <a:prstGeom prst="rect">
+            <a:avLst/>
+          </a:prstGeom>
+          <a:solidFill>
+            <a:srgbClr val="E82127"/>
+          </a:solidFill>
+          <a:ln>
+            <a:noFill/>
+          </a:ln>
+        </p:spPr>
+        <p:style>
+          <a:lnRef idx="1">
+            <a:schemeClr val="accent1"/>
+          </a:lnRef>
+          <a:fillRef idx="3">
+            <a:schemeClr val="accent1"/>
+          </a:fillRef>
+          <a:effectRef idx="2">
+            <a:schemeClr val="accent1"/>
+          </a:effectRef>
+          <a:fontRef idx="minor">
+            <a:schemeClr val="lt1"/>
+          </a:fontRef>
+        </p:style>
+        <p:txBody>
+          <a:bodyPr rtlCol="0" anchor="ctr"/>
+          <a:lstStyle/>
+          <a:p>
+            <a:pPr algn="ctr"/>
+          </a:p>
+        </p:txBody>
+      </p:sp>
+      <p:sp>
+        <p:nvSpPr>
+          <p:cNvPr id="3" name="TextBox 2"/>
           <p:cNvSpPr txBox="1"/>
           <p:nvPr/>
         </p:nvSpPr>
@@ -4590,25 +5776,80 @@
             <a:r>
               <a:rPr sz="4000" b="1" lang="he-IL" altLang="en-US">
                 <a:solidFill>
-                  <a:srgbClr val="1B3A6B"/>
+                  <a:srgbClr val="171A20"/>
                 </a:solidFill>
                 <a:latin typeface="Arial"/>
               </a:rPr>
-              <a:t>מתי נקבל אותה?</a:t>
-            </a:r>
-          </a:p>
-        </p:txBody>
-      </p:sp>
-      <p:sp>
-        <p:nvSpPr>
-          <p:cNvPr id="3" name="Rounded Rectangle 2"/>
+              <a:t>למה זה חשוב, ומה אנחנו חושבים?</a:t>
+            </a:r>
+          </a:p>
+        </p:txBody>
+      </p:sp>
+      <p:sp>
+        <p:nvSpPr>
+          <p:cNvPr id="4" name="TextBox 3"/>
+          <p:cNvSpPr txBox="1"/>
+          <p:nvPr/>
+        </p:nvSpPr>
+        <p:spPr>
+          <a:xfrm>
+            <a:off x="548640" y="1371600"/>
+            <a:ext cx="11064240" cy="2377440"/>
+          </a:xfrm>
+          <a:prstGeom prst="rect">
+            <a:avLst/>
+          </a:prstGeom>
+          <a:noFill/>
+        </p:spPr>
+        <p:txBody>
+          <a:bodyPr wrap="square" anchor="t">
+            <a:spAutoFit/>
+          </a:bodyPr>
+          <a:lstStyle/>
+          <a:p>
+            <a:pPr algn="r" rtl="1">
+              <a:spcAft>
+                <a:spcPts val="1000"/>
+              </a:spcAft>
+            </a:pPr>
+            <a:r>
+              <a:rPr sz="2400" b="0" lang="he-IL" altLang="en-US">
+                <a:solidFill>
+                  <a:srgbClr val="171A20"/>
+                </a:solidFill>
+                <a:latin typeface="Arial"/>
+              </a:rPr>
+              <a:t>למה זה חשוב? ההדגמה מראה איך חברות משתפות פעולה כדי לנסות דברים שלא נעשו לפני, גם כשזה נראה מסוכן.</a:t>
+            </a:r>
+          </a:p>
+          <a:p>
+            <a:pPr algn="r" rtl="1">
+              <a:spcAft>
+                <a:spcPts val="1000"/>
+              </a:spcAft>
+            </a:pPr>
+            <a:r>
+              <a:rPr sz="2400" b="0" lang="he-IL" altLang="en-US">
+                <a:solidFill>
+                  <a:srgbClr val="171A20"/>
+                </a:solidFill>
+                <a:latin typeface="Arial"/>
+              </a:rPr>
+              <a:t>מה אנחנו חושבים? אילון מאסק הוא מוביל חכם וחדשן, שמביא פיתוחים חדשים לעולם, כולל רכב חשמלי. אבל ההדגמה מראה שהחלום לרכב שמתעופף עדיין רחוק מהמוצר שאפשר לקנות.</a:t>
+            </a:r>
+          </a:p>
+        </p:txBody>
+      </p:sp>
+      <p:sp>
+        <p:nvSpPr>
+          <p:cNvPr id="5" name="Rounded Rectangle 4"/>
           <p:cNvSpPr/>
           <p:nvPr/>
         </p:nvSpPr>
         <p:spPr>
           <a:xfrm>
-            <a:off x="548640" y="1554480"/>
-            <a:ext cx="5394960" cy="2011680"/>
+            <a:off x="548640" y="4297680"/>
+            <a:ext cx="11064240" cy="1737360"/>
           </a:xfrm>
           <a:prstGeom prst="roundRect">
             <a:avLst>
@@ -4616,7 +5857,7 @@
             </a:avLst>
           </a:prstGeom>
           <a:solidFill>
-            <a:srgbClr val="FF8C28"/>
+            <a:srgbClr val="A81018"/>
           </a:solidFill>
           <a:ln>
             <a:noFill/>
@@ -4648,7 +5889,7 @@
                 </a:solidFill>
                 <a:latin typeface="Arial"/>
               </a:rPr>
-              <a:t>ייצור ב-2028?</a:t>
+              <a:t>שאלה לדיון</a:t>
             </a:r>
           </a:p>
           <a:p>
@@ -4660,205 +5901,7 @@
                 </a:solidFill>
                 <a:latin typeface="Arial"/>
               </a:rPr>
-              <a:t>מוסק אמר שהייצור ללקוחות יתחיל ב-2028. זו תוכנית, לא הבטחה</a:t>
-            </a:r>
-          </a:p>
-        </p:txBody>
-      </p:sp>
-      <p:sp>
-        <p:nvSpPr>
-          <p:cNvPr id="4" name="Rounded Rectangle 3"/>
-          <p:cNvSpPr/>
-          <p:nvPr/>
-        </p:nvSpPr>
-        <p:spPr>
-          <a:xfrm>
-            <a:off x="6309360" y="1554480"/>
-            <a:ext cx="5394960" cy="2011680"/>
-          </a:xfrm>
-          <a:prstGeom prst="roundRect">
-            <a:avLst>
-              <a:gd name="adj" fmla="val 12000"/>
-            </a:avLst>
-          </a:prstGeom>
-          <a:solidFill>
-            <a:srgbClr val="3BA55D"/>
-          </a:solidFill>
-          <a:ln>
-            <a:noFill/>
-          </a:ln>
-        </p:spPr>
-        <p:style>
-          <a:lnRef idx="1">
-            <a:schemeClr val="accent1"/>
-          </a:lnRef>
-          <a:fillRef idx="3">
-            <a:schemeClr val="accent1"/>
-          </a:fillRef>
-          <a:effectRef idx="2">
-            <a:schemeClr val="accent1"/>
-          </a:effectRef>
-          <a:fontRef idx="minor">
-            <a:schemeClr val="lt1"/>
-          </a:fontRef>
-        </p:style>
-        <p:txBody>
-          <a:bodyPr rtlCol="0" anchor="ctr" wrap="square" lIns="228600" rIns="228600"/>
-          <a:lstStyle/>
-          <a:p>
-            <a:pPr algn="r" rtl="1"/>
-            <a:r>
-              <a:rPr sz="2600" b="1" lang="he-IL" altLang="en-US">
-                <a:solidFill>
-                  <a:srgbClr val="FFFFFF"/>
-                </a:solidFill>
-                <a:latin typeface="Arial"/>
-              </a:rPr>
-              <a:t>עוד אין מחיר</a:t>
-            </a:r>
-          </a:p>
-          <a:p>
-            <a:pPr algn="r" rtl="1"/>
-            <a:r>
-              <a:rPr sz="2000" b="0" lang="he-IL" altLang="en-US">
-                <a:solidFill>
-                  <a:srgbClr val="FFFFFF"/>
-                </a:solidFill>
-                <a:latin typeface="Arial"/>
-              </a:rPr>
-              <a:t>עדיין לא פורסם מחיר לרכב</a:t>
-            </a:r>
-          </a:p>
-        </p:txBody>
-      </p:sp>
-      <p:sp>
-        <p:nvSpPr>
-          <p:cNvPr id="5" name="Rounded Rectangle 4"/>
-          <p:cNvSpPr/>
-          <p:nvPr/>
-        </p:nvSpPr>
-        <p:spPr>
-          <a:xfrm>
-            <a:off x="548640" y="3840480"/>
-            <a:ext cx="5394960" cy="2011680"/>
-          </a:xfrm>
-          <a:prstGeom prst="roundRect">
-            <a:avLst>
-              <a:gd name="adj" fmla="val 12000"/>
-            </a:avLst>
-          </a:prstGeom>
-          <a:solidFill>
-            <a:srgbClr val="E85D9B"/>
-          </a:solidFill>
-          <a:ln>
-            <a:noFill/>
-          </a:ln>
-        </p:spPr>
-        <p:style>
-          <a:lnRef idx="1">
-            <a:schemeClr val="accent1"/>
-          </a:lnRef>
-          <a:fillRef idx="3">
-            <a:schemeClr val="accent1"/>
-          </a:fillRef>
-          <a:effectRef idx="2">
-            <a:schemeClr val="accent1"/>
-          </a:effectRef>
-          <a:fontRef idx="minor">
-            <a:schemeClr val="lt1"/>
-          </a:fontRef>
-        </p:style>
-        <p:txBody>
-          <a:bodyPr rtlCol="0" anchor="ctr" wrap="square" lIns="228600" rIns="228600"/>
-          <a:lstStyle/>
-          <a:p>
-            <a:pPr algn="r" rtl="1"/>
-            <a:r>
-              <a:rPr sz="2600" b="1" lang="he-IL" altLang="en-US">
-                <a:solidFill>
-                  <a:srgbClr val="FFFFFF"/>
-                </a:solidFill>
-                <a:latin typeface="Arial"/>
-              </a:rPr>
-              <a:t>אישור רשמי חסר</a:t>
-            </a:r>
-          </a:p>
-          <a:p>
-            <a:pPr algn="r" rtl="1"/>
-            <a:r>
-              <a:rPr sz="2000" b="0" lang="he-IL" altLang="en-US">
-                <a:solidFill>
-                  <a:srgbClr val="FFFFFF"/>
-                </a:solidFill>
-                <a:latin typeface="Arial"/>
-              </a:rPr>
-              <a:t>הרשות האמריקאית לתעופה (FAA) עדיין לא אישרה את הרכב</a:t>
-            </a:r>
-          </a:p>
-        </p:txBody>
-      </p:sp>
-      <p:sp>
-        <p:nvSpPr>
-          <p:cNvPr id="6" name="Rounded Rectangle 5"/>
-          <p:cNvSpPr/>
-          <p:nvPr/>
-        </p:nvSpPr>
-        <p:spPr>
-          <a:xfrm>
-            <a:off x="6309360" y="3840480"/>
-            <a:ext cx="5394960" cy="2011680"/>
-          </a:xfrm>
-          <a:prstGeom prst="roundRect">
-            <a:avLst>
-              <a:gd name="adj" fmla="val 12000"/>
-            </a:avLst>
-          </a:prstGeom>
-          <a:solidFill>
-            <a:srgbClr val="1B3A6B"/>
-          </a:solidFill>
-          <a:ln>
-            <a:noFill/>
-          </a:ln>
-        </p:spPr>
-        <p:style>
-          <a:lnRef idx="1">
-            <a:schemeClr val="accent1"/>
-          </a:lnRef>
-          <a:fillRef idx="3">
-            <a:schemeClr val="accent1"/>
-          </a:fillRef>
-          <a:effectRef idx="2">
-            <a:schemeClr val="accent1"/>
-          </a:effectRef>
-          <a:fontRef idx="minor">
-            <a:schemeClr val="lt1"/>
-          </a:fontRef>
-        </p:style>
-        <p:txBody>
-          <a:bodyPr rtlCol="0" anchor="ctr" wrap="square" lIns="228600" rIns="228600"/>
-          <a:lstStyle/>
-          <a:p>
-            <a:pPr algn="r" rtl="1"/>
-            <a:r>
-              <a:rPr sz="2600" b="1" lang="he-IL" altLang="en-US">
-                <a:solidFill>
-                  <a:srgbClr val="FFFFFF"/>
-                </a:solidFill>
-                <a:latin typeface="Arial"/>
-              </a:rPr>
-              <a:t>לא בטוח שייסע בכבישים</a:t>
-            </a:r>
-          </a:p>
-          <a:p>
-            <a:pPr algn="r" rtl="1"/>
-            <a:r>
-              <a:rPr sz="2000" b="0" lang="he-IL" altLang="en-US">
-                <a:solidFill>
-                  <a:srgbClr val="FFFFFF"/>
-                </a:solidFill>
-                <a:latin typeface="Arial"/>
-              </a:rPr>
-              <a:t>מומחה לחוק אמר שזו מכונית חד-פעמית שלא תגיע לכבישים ב-2028</a:t>
+              <a:t>מה דעתכם? האם חדשנות צריכה להיות מהירה, או בטוחה ומדויקת?</a:t>
             </a:r>
           </a:p>
         </p:txBody>
@@ -4871,13 +5914,13 @@
 </p:sld>
 </file>
 
-<file path=ppt/slides/slide5.xml><?xml version="1.0" encoding="utf-8"?>
+<file path=ppt/slides/slide7.xml><?xml version="1.0" encoding="utf-8"?>
 <p:sld xmlns:a="http://schemas.openxmlformats.org/drawingml/2006/main" xmlns:p="http://schemas.openxmlformats.org/presentationml/2006/main" xmlns:r="http://schemas.openxmlformats.org/officeDocument/2006/relationships">
   <p:cSld>
     <p:bg>
       <p:bgPr>
         <a:solidFill>
-          <a:srgbClr val="FFF8E7"/>
+          <a:srgbClr val="F4F4F4"/>
         </a:solidFill>
         <a:effectLst/>
       </p:bgPr>
@@ -4891,7 +5934,50 @@
       <p:grpSpPr/>
       <p:sp>
         <p:nvSpPr>
-          <p:cNvPr id="2" name="TextBox 1"/>
+          <p:cNvPr id="2" name="Rectangle 1"/>
+          <p:cNvSpPr/>
+          <p:nvPr/>
+        </p:nvSpPr>
+        <p:spPr>
+          <a:xfrm>
+            <a:off x="0" y="0"/>
+            <a:ext cx="12191695" cy="109728"/>
+          </a:xfrm>
+          <a:prstGeom prst="rect">
+            <a:avLst/>
+          </a:prstGeom>
+          <a:solidFill>
+            <a:srgbClr val="E82127"/>
+          </a:solidFill>
+          <a:ln>
+            <a:noFill/>
+          </a:ln>
+        </p:spPr>
+        <p:style>
+          <a:lnRef idx="1">
+            <a:schemeClr val="accent1"/>
+          </a:lnRef>
+          <a:fillRef idx="3">
+            <a:schemeClr val="accent1"/>
+          </a:fillRef>
+          <a:effectRef idx="2">
+            <a:schemeClr val="accent1"/>
+          </a:effectRef>
+          <a:fontRef idx="minor">
+            <a:schemeClr val="lt1"/>
+          </a:fontRef>
+        </p:style>
+        <p:txBody>
+          <a:bodyPr rtlCol="0" anchor="ctr"/>
+          <a:lstStyle/>
+          <a:p>
+            <a:pPr algn="ctr"/>
+          </a:p>
+        </p:txBody>
+      </p:sp>
+      <p:sp>
+        <p:nvSpPr>
+          <p:cNvPr id="3" name="TextBox 2"/>
           <p:cNvSpPr txBox="1"/>
           <p:nvPr/>
         </p:nvSpPr>
@@ -4919,25 +6005,25 @@
             <a:r>
               <a:rPr sz="4000" b="1" lang="he-IL" altLang="en-US">
                 <a:solidFill>
-                  <a:srgbClr val="1B3A6B"/>
+                  <a:srgbClr val="171A20"/>
                 </a:solidFill>
                 <a:latin typeface="Arial"/>
               </a:rPr>
-              <a:t>הדגמה היא לא מוצר</a:t>
-            </a:r>
-          </a:p>
-        </p:txBody>
-      </p:sp>
-      <p:sp>
-        <p:nvSpPr>
-          <p:cNvPr id="3" name="Rounded Rectangle 2"/>
+              <a:t>הסרטון והכתבה בעברית</a:t>
+            </a:r>
+          </a:p>
+        </p:txBody>
+      </p:sp>
+      <p:sp>
+        <p:nvSpPr>
+          <p:cNvPr id="4" name="Rounded Rectangle 3"/>
           <p:cNvSpPr/>
           <p:nvPr/>
         </p:nvSpPr>
         <p:spPr>
           <a:xfrm>
-            <a:off x="548640" y="1554480"/>
-            <a:ext cx="3566160" cy="2194560"/>
+            <a:off x="548640" y="1463040"/>
+            <a:ext cx="5394960" cy="2377440"/>
           </a:xfrm>
           <a:prstGeom prst="roundRect">
             <a:avLst>
@@ -4945,7 +6031,7 @@
             </a:avLst>
           </a:prstGeom>
           <a:solidFill>
-            <a:srgbClr val="FF8C28"/>
+            <a:srgbClr val="171A20"/>
           </a:solidFill>
           <a:ln>
             <a:noFill/>
@@ -4977,7 +6063,7 @@
                 </a:solidFill>
                 <a:latin typeface="Arial"/>
               </a:rPr>
-              <a:t>שאלו שאלות</a:t>
+              <a:t>הסרטון כפי שפורסם באתר חדשות</a:t>
             </a:r>
           </a:p>
           <a:p>
@@ -4989,21 +6075,57 @@
                 </a:solidFill>
                 <a:latin typeface="Arial"/>
               </a:rPr>
-              <a:t>מה נבדק, ומה עוד לא?</a:t>
-            </a:r>
-          </a:p>
-        </p:txBody>
-      </p:sp>
-      <p:sp>
-        <p:nvSpPr>
-          <p:cNvPr id="4" name="Rounded Rectangle 3"/>
+              <a:t>CNN. לחצו על הקישור לצפייה בסרטון הרשמי של ההדגמה, לא מוטמע כאן</a:t>
+            </a:r>
+          </a:p>
+        </p:txBody>
+      </p:sp>
+      <p:sp>
+        <p:nvSpPr>
+          <p:cNvPr id="5" name="TextBox 4"/>
+          <p:cNvSpPr txBox="1"/>
+          <p:nvPr/>
+        </p:nvSpPr>
+        <p:spPr>
+          <a:xfrm>
+            <a:off x="822960" y="3291840"/>
+            <a:ext cx="4937760" cy="548640"/>
+          </a:xfrm>
+          <a:prstGeom prst="rect">
+            <a:avLst/>
+          </a:prstGeom>
+          <a:noFill/>
+        </p:spPr>
+        <p:txBody>
+          <a:bodyPr wrap="square">
+            <a:spAutoFit/>
+          </a:bodyPr>
+          <a:lstStyle/>
+          <a:p>
+            <a:pPr algn="r" rtl="1"/>
+            <a:r>
+              <a:rPr sz="2000" b="1" lang="he-IL" altLang="en-US">
+                <a:solidFill>
+                  <a:srgbClr val="B01A20"/>
+                </a:solidFill>
+                <a:latin typeface="Arial"/>
+                <a:hlinkClick r:id="rId2"/>
+              </a:rPr>
+              <a:t>לצפייה בסרטון ב-CNN</a:t>
+            </a:r>
+          </a:p>
+        </p:txBody>
+      </p:sp>
+      <p:sp>
+        <p:nvSpPr>
+          <p:cNvPr id="6" name="Rounded Rectangle 5"/>
           <p:cNvSpPr/>
           <p:nvPr/>
         </p:nvSpPr>
         <p:spPr>
           <a:xfrm>
-            <a:off x="4297679" y="1554480"/>
-            <a:ext cx="3566160" cy="2194560"/>
+            <a:off x="6217920" y="1463040"/>
+            <a:ext cx="5394960" cy="2377440"/>
           </a:xfrm>
           <a:prstGeom prst="roundRect">
             <a:avLst>
@@ -5011,7 +6133,7 @@
             </a:avLst>
           </a:prstGeom>
           <a:solidFill>
-            <a:srgbClr val="3BA55D"/>
+            <a:srgbClr val="E82127"/>
           </a:solidFill>
           <a:ln>
             <a:noFill/>
@@ -5043,7 +6165,7 @@
                 </a:solidFill>
                 <a:latin typeface="Arial"/>
               </a:rPr>
-              <a:t>בדקו מקורות</a:t>
+              <a:t>כתבה בעברית</a:t>
             </a:r>
           </a:p>
           <a:p>
@@ -5055,21 +6177,204 @@
                 </a:solidFill>
                 <a:latin typeface="Arial"/>
               </a:rPr>
-              <a:t>לפני שמאמינים לכותרת, מחפשים את הפרטים</a:t>
-            </a:r>
-          </a:p>
-        </p:txBody>
-      </p:sp>
-      <p:sp>
-        <p:nvSpPr>
-          <p:cNvPr id="5" name="Rounded Rectangle 4"/>
+              <a:t>i24NEWS: הכתבה מתארת את ההדגמה ואת טענות מאסק על התמרונים</a:t>
+            </a:r>
+          </a:p>
+        </p:txBody>
+      </p:sp>
+      <p:sp>
+        <p:nvSpPr>
+          <p:cNvPr id="7" name="TextBox 6"/>
+          <p:cNvSpPr txBox="1"/>
+          <p:nvPr/>
+        </p:nvSpPr>
+        <p:spPr>
+          <a:xfrm>
+            <a:off x="6492240" y="3291840"/>
+            <a:ext cx="4937760" cy="548640"/>
+          </a:xfrm>
+          <a:prstGeom prst="rect">
+            <a:avLst/>
+          </a:prstGeom>
+          <a:noFill/>
+        </p:spPr>
+        <p:txBody>
+          <a:bodyPr wrap="square">
+            <a:spAutoFit/>
+          </a:bodyPr>
+          <a:lstStyle/>
+          <a:p>
+            <a:pPr algn="r" rtl="1"/>
+            <a:r>
+              <a:rPr sz="2000" b="1" lang="he-IL" altLang="en-US">
+                <a:solidFill>
+                  <a:srgbClr val="B01A20"/>
+                </a:solidFill>
+                <a:latin typeface="Arial"/>
+                <a:hlinkClick r:id="rId3"/>
+              </a:rPr>
+              <a:t>לקריאת הכתבה ב-i24NEWS</a:t>
+            </a:r>
+          </a:p>
+        </p:txBody>
+      </p:sp>
+      <p:sp>
+        <p:nvSpPr>
+          <p:cNvPr id="8" name="TextBox 7"/>
+          <p:cNvSpPr txBox="1"/>
+          <p:nvPr/>
+        </p:nvSpPr>
+        <p:spPr>
+          <a:xfrm>
+            <a:off x="548640" y="4206240"/>
+            <a:ext cx="11064240" cy="2194560"/>
+          </a:xfrm>
+          <a:prstGeom prst="rect">
+            <a:avLst/>
+          </a:prstGeom>
+          <a:noFill/>
+        </p:spPr>
+        <p:txBody>
+          <a:bodyPr wrap="square" anchor="t">
+            <a:spAutoFit/>
+          </a:bodyPr>
+          <a:lstStyle/>
+          <a:p>
+            <a:pPr algn="r" rtl="1">
+              <a:spcAft>
+                <a:spcPts val="1000"/>
+              </a:spcAft>
+            </a:pPr>
+            <a:r>
+              <a:rPr sz="2200" b="0" lang="he-IL" altLang="en-US">
+                <a:solidFill>
+                  <a:srgbClr val="171A20"/>
+                </a:solidFill>
+                <a:latin typeface="Arial"/>
+              </a:rPr>
+              <a:t>מה הכתבה אומרת, במילים שלנו: טסלה חשפה את הדור החדש של הרודסטר. מאסק טען שהרכב יכול להתרומם ולבצע תמרונים. ההדגמה נערכה במתקן של SpaceX בטקסס, לא הוצגה טיסה ממושכת, ולא נמסר תאריך מסירה ללקוחות.</a:t>
+            </a:r>
+          </a:p>
+        </p:txBody>
+      </p:sp>
+    </p:spTree>
+  </p:cSld>
+  <p:clrMapOvr>
+    <a:masterClrMapping/>
+  </p:clrMapOvr>
+</p:sld>
+</file>
+
+<file path=ppt/slides/slide8.xml><?xml version="1.0" encoding="utf-8"?>
+<p:sld xmlns:a="http://schemas.openxmlformats.org/drawingml/2006/main" xmlns:p="http://schemas.openxmlformats.org/presentationml/2006/main" xmlns:r="http://schemas.openxmlformats.org/officeDocument/2006/relationships">
+  <p:cSld>
+    <p:bg>
+      <p:bgPr>
+        <a:solidFill>
+          <a:srgbClr val="F4F4F4"/>
+        </a:solidFill>
+        <a:effectLst/>
+      </p:bgPr>
+    </p:bg>
+    <p:spTree>
+      <p:nvGrpSpPr>
+        <p:cNvPr id="1" name=""/>
+        <p:cNvGrpSpPr/>
+        <p:nvPr/>
+      </p:nvGrpSpPr>
+      <p:grpSpPr/>
+      <p:sp>
+        <p:nvSpPr>
+          <p:cNvPr id="2" name="Rectangle 1"/>
           <p:cNvSpPr/>
           <p:nvPr/>
         </p:nvSpPr>
         <p:spPr>
           <a:xfrm>
-            <a:off x="8046718" y="1554480"/>
-            <a:ext cx="3566160" cy="2194560"/>
+            <a:off x="0" y="0"/>
+            <a:ext cx="12191695" cy="109728"/>
+          </a:xfrm>
+          <a:prstGeom prst="rect">
+            <a:avLst/>
+          </a:prstGeom>
+          <a:solidFill>
+            <a:srgbClr val="E82127"/>
+          </a:solidFill>
+          <a:ln>
+            <a:noFill/>
+          </a:ln>
+        </p:spPr>
+        <p:style>
+          <a:lnRef idx="1">
+            <a:schemeClr val="accent1"/>
+          </a:lnRef>
+          <a:fillRef idx="3">
+            <a:schemeClr val="accent1"/>
+          </a:fillRef>
+          <a:effectRef idx="2">
+            <a:schemeClr val="accent1"/>
+          </a:effectRef>
+          <a:fontRef idx="minor">
+            <a:schemeClr val="lt1"/>
+          </a:fontRef>
+        </p:style>
+        <p:txBody>
+          <a:bodyPr rtlCol="0" anchor="ctr"/>
+          <a:lstStyle/>
+          <a:p>
+            <a:pPr algn="ctr"/>
+          </a:p>
+        </p:txBody>
+      </p:sp>
+      <p:sp>
+        <p:nvSpPr>
+          <p:cNvPr id="3" name="TextBox 2"/>
+          <p:cNvSpPr txBox="1"/>
+          <p:nvPr/>
+        </p:nvSpPr>
+        <p:spPr>
+          <a:xfrm>
+            <a:off x="548640" y="320040"/>
+            <a:ext cx="11094415" cy="914400"/>
+          </a:xfrm>
+          <a:prstGeom prst="rect">
+            <a:avLst/>
+          </a:prstGeom>
+          <a:noFill/>
+        </p:spPr>
+        <p:txBody>
+          <a:bodyPr wrap="square" anchor="t">
+            <a:spAutoFit/>
+          </a:bodyPr>
+          <a:lstStyle/>
+          <a:p>
+            <a:pPr algn="r" rtl="1">
+              <a:spcAft>
+                <a:spcPts val="1000"/>
+              </a:spcAft>
+            </a:pPr>
+            <a:r>
+              <a:rPr sz="4000" b="1" lang="he-IL" altLang="en-US">
+                <a:solidFill>
+                  <a:srgbClr val="171A20"/>
+                </a:solidFill>
+                <a:latin typeface="Arial"/>
+              </a:rPr>
+              <a:t>הסיפור בכל דרך</a:t>
+            </a:r>
+          </a:p>
+        </p:txBody>
+      </p:sp>
+      <p:sp>
+        <p:nvSpPr>
+          <p:cNvPr id="4" name="Rounded Rectangle 3"/>
+          <p:cNvSpPr/>
+          <p:nvPr/>
+        </p:nvSpPr>
+        <p:spPr>
+          <a:xfrm>
+            <a:off x="548640" y="1463040"/>
+            <a:ext cx="2651760" cy="2103120"/>
           </a:xfrm>
           <a:prstGeom prst="roundRect">
             <a:avLst>
@@ -5077,7 +6382,7 @@
             </a:avLst>
           </a:prstGeom>
           <a:solidFill>
-            <a:srgbClr val="E85D9B"/>
+            <a:srgbClr val="E82127"/>
           </a:solidFill>
           <a:ln>
             <a:noFill/>
@@ -5098,7 +6403,7 @@
           </a:fontRef>
         </p:style>
         <p:txBody>
-          <a:bodyPr rtlCol="0" anchor="ctr" wrap="square" lIns="228600" rIns="228600"/>
+          <a:bodyPr rtlCol="0" anchor="ctr" wrap="square" lIns="1143000" rIns="228600"/>
           <a:lstStyle/>
           <a:p>
             <a:pPr algn="r" rtl="1"/>
@@ -5109,7 +6414,7 @@
                 </a:solidFill>
                 <a:latin typeface="Arial"/>
               </a:rPr>
-              <a:t>חלמו, ותבחנו</a:t>
+              <a:t>סרטון</a:t>
             </a:r>
           </a:p>
           <a:p>
@@ -5121,21 +6426,107 @@
                 </a:solidFill>
                 <a:latin typeface="Arial"/>
               </a:rPr>
-              <a:t>חלום טוב גם צריך בדיקות</a:t>
-            </a:r>
-          </a:p>
-        </p:txBody>
-      </p:sp>
-      <p:sp>
-        <p:nvSpPr>
-          <p:cNvPr id="6" name="Rounded Rectangle 5"/>
+              <a:t>האנימציה בשקף 5</a:t>
+            </a:r>
+          </a:p>
+        </p:txBody>
+      </p:sp>
+      <p:sp>
+        <p:nvSpPr>
+          <p:cNvPr id="5" name="Oval 4"/>
           <p:cNvSpPr/>
           <p:nvPr/>
         </p:nvSpPr>
         <p:spPr>
           <a:xfrm>
-            <a:off x="548640" y="4206240"/>
-            <a:ext cx="11094415" cy="1737360"/>
+            <a:off x="822960" y="2194560"/>
+            <a:ext cx="640080" cy="640080"/>
+          </a:xfrm>
+          <a:prstGeom prst="ellipse">
+            <a:avLst/>
+          </a:prstGeom>
+          <a:solidFill>
+            <a:srgbClr val="FFFFFF"/>
+          </a:solidFill>
+          <a:ln>
+            <a:noFill/>
+          </a:ln>
+        </p:spPr>
+        <p:style>
+          <a:lnRef idx="1">
+            <a:schemeClr val="accent1"/>
+          </a:lnRef>
+          <a:fillRef idx="3">
+            <a:schemeClr val="accent1"/>
+          </a:fillRef>
+          <a:effectRef idx="2">
+            <a:schemeClr val="accent1"/>
+          </a:effectRef>
+          <a:fontRef idx="minor">
+            <a:schemeClr val="lt1"/>
+          </a:fontRef>
+        </p:style>
+        <p:txBody>
+          <a:bodyPr rtlCol="0" anchor="ctr"/>
+          <a:lstStyle/>
+          <a:p>
+            <a:pPr algn="ctr"/>
+          </a:p>
+        </p:txBody>
+      </p:sp>
+      <p:sp>
+        <p:nvSpPr>
+          <p:cNvPr id="6" name="Isosceles Triangle 5"/>
+          <p:cNvSpPr/>
+          <p:nvPr/>
+        </p:nvSpPr>
+        <p:spPr>
+          <a:xfrm>
+            <a:off x="966978" y="2338578"/>
+            <a:ext cx="352044" cy="352044"/>
+          </a:xfrm>
+          <a:prstGeom prst="triangle">
+            <a:avLst/>
+          </a:prstGeom>
+          <a:solidFill>
+            <a:srgbClr val="E82127"/>
+          </a:solidFill>
+          <a:ln>
+            <a:noFill/>
+          </a:ln>
+        </p:spPr>
+        <p:style>
+          <a:lnRef idx="1">
+            <a:schemeClr val="accent1"/>
+          </a:lnRef>
+          <a:fillRef idx="3">
+            <a:schemeClr val="accent1"/>
+          </a:fillRef>
+          <a:effectRef idx="2">
+            <a:schemeClr val="accent1"/>
+          </a:effectRef>
+          <a:fontRef idx="minor">
+            <a:schemeClr val="lt1"/>
+          </a:fontRef>
+        </p:style>
+        <p:txBody>
+          <a:bodyPr rtlCol="0" anchor="ctr"/>
+          <a:lstStyle/>
+          <a:p>
+            <a:pPr algn="ctr"/>
+          </a:p>
+        </p:txBody>
+      </p:sp>
+      <p:sp>
+        <p:nvSpPr>
+          <p:cNvPr id="7" name="Rounded Rectangle 6"/>
+          <p:cNvSpPr/>
+          <p:nvPr/>
+        </p:nvSpPr>
+        <p:spPr>
+          <a:xfrm>
+            <a:off x="3383280" y="1463040"/>
+            <a:ext cx="2651760" cy="2103120"/>
           </a:xfrm>
           <a:prstGeom prst="roundRect">
             <a:avLst>
@@ -5143,7 +6534,7 @@
             </a:avLst>
           </a:prstGeom>
           <a:solidFill>
-            <a:srgbClr val="FFD54F"/>
+            <a:srgbClr val="171A20"/>
           </a:solidFill>
           <a:ln>
             <a:noFill/>
@@ -5164,18 +6555,18 @@
           </a:fontRef>
         </p:style>
         <p:txBody>
-          <a:bodyPr rtlCol="0" anchor="ctr" wrap="square" lIns="228600" rIns="228600"/>
+          <a:bodyPr rtlCol="0" anchor="ctr" wrap="square" lIns="1143000" rIns="228600"/>
           <a:lstStyle/>
           <a:p>
             <a:pPr algn="r" rtl="1"/>
             <a:r>
               <a:rPr sz="2600" b="1" lang="he-IL" altLang="en-US">
                 <a:solidFill>
-                  <a:srgbClr val="222233"/>
+                  <a:srgbClr val="FFFFFF"/>
                 </a:solidFill>
                 <a:latin typeface="Arial"/>
               </a:rPr>
-              <a:t>שאלה לדיון</a:t>
+              <a:t>תמונה</a:t>
             </a:r>
           </a:p>
           <a:p>
@@ -5183,11 +6574,543 @@
             <a:r>
               <a:rPr sz="2000" b="0" lang="he-IL" altLang="en-US">
                 <a:solidFill>
-                  <a:srgbClr val="222233"/>
+                  <a:srgbClr val="FFFFFF"/>
                 </a:solidFill>
                 <a:latin typeface="Arial"/>
               </a:rPr>
-              <a:t>מה חשוב לבדוק לפני שקונים מוצר חדש?</a:t>
+              <a:t>תמונת מאסק בשקף 4</a:t>
+            </a:r>
+          </a:p>
+        </p:txBody>
+      </p:sp>
+      <p:sp>
+        <p:nvSpPr>
+          <p:cNvPr id="8" name="Oval 7"/>
+          <p:cNvSpPr/>
+          <p:nvPr/>
+        </p:nvSpPr>
+        <p:spPr>
+          <a:xfrm>
+            <a:off x="3657600" y="2194560"/>
+            <a:ext cx="640080" cy="640080"/>
+          </a:xfrm>
+          <a:prstGeom prst="ellipse">
+            <a:avLst/>
+          </a:prstGeom>
+          <a:solidFill>
+            <a:srgbClr val="FFFFFF"/>
+          </a:solidFill>
+          <a:ln>
+            <a:noFill/>
+          </a:ln>
+        </p:spPr>
+        <p:style>
+          <a:lnRef idx="1">
+            <a:schemeClr val="accent1"/>
+          </a:lnRef>
+          <a:fillRef idx="3">
+            <a:schemeClr val="accent1"/>
+          </a:fillRef>
+          <a:effectRef idx="2">
+            <a:schemeClr val="accent1"/>
+          </a:effectRef>
+          <a:fontRef idx="minor">
+            <a:schemeClr val="lt1"/>
+          </a:fontRef>
+        </p:style>
+        <p:txBody>
+          <a:bodyPr rtlCol="0" anchor="ctr"/>
+          <a:lstStyle/>
+          <a:p>
+            <a:pPr algn="ctr"/>
+          </a:p>
+        </p:txBody>
+      </p:sp>
+      <p:sp>
+        <p:nvSpPr>
+          <p:cNvPr id="9" name="Frame 8"/>
+          <p:cNvSpPr/>
+          <p:nvPr/>
+        </p:nvSpPr>
+        <p:spPr>
+          <a:xfrm>
+            <a:off x="3801618" y="2338578"/>
+            <a:ext cx="352044" cy="352044"/>
+          </a:xfrm>
+          <a:prstGeom prst="frame">
+            <a:avLst/>
+          </a:prstGeom>
+          <a:solidFill>
+            <a:srgbClr val="171A20"/>
+          </a:solidFill>
+          <a:ln>
+            <a:noFill/>
+          </a:ln>
+        </p:spPr>
+        <p:style>
+          <a:lnRef idx="1">
+            <a:schemeClr val="accent1"/>
+          </a:lnRef>
+          <a:fillRef idx="3">
+            <a:schemeClr val="accent1"/>
+          </a:fillRef>
+          <a:effectRef idx="2">
+            <a:schemeClr val="accent1"/>
+          </a:effectRef>
+          <a:fontRef idx="minor">
+            <a:schemeClr val="lt1"/>
+          </a:fontRef>
+        </p:style>
+        <p:txBody>
+          <a:bodyPr rtlCol="0" anchor="ctr"/>
+          <a:lstStyle/>
+          <a:p>
+            <a:pPr algn="ctr"/>
+          </a:p>
+        </p:txBody>
+      </p:sp>
+      <p:sp>
+        <p:nvSpPr>
+          <p:cNvPr id="10" name="Rounded Rectangle 9"/>
+          <p:cNvSpPr/>
+          <p:nvPr/>
+        </p:nvSpPr>
+        <p:spPr>
+          <a:xfrm>
+            <a:off x="6217920" y="1463040"/>
+            <a:ext cx="2651760" cy="2103120"/>
+          </a:xfrm>
+          <a:prstGeom prst="roundRect">
+            <a:avLst>
+              <a:gd name="adj" fmla="val 12000"/>
+            </a:avLst>
+          </a:prstGeom>
+          <a:solidFill>
+            <a:srgbClr val="5C5E62"/>
+          </a:solidFill>
+          <a:ln>
+            <a:noFill/>
+          </a:ln>
+        </p:spPr>
+        <p:style>
+          <a:lnRef idx="1">
+            <a:schemeClr val="accent1"/>
+          </a:lnRef>
+          <a:fillRef idx="3">
+            <a:schemeClr val="accent1"/>
+          </a:fillRef>
+          <a:effectRef idx="2">
+            <a:schemeClr val="accent1"/>
+          </a:effectRef>
+          <a:fontRef idx="minor">
+            <a:schemeClr val="lt1"/>
+          </a:fontRef>
+        </p:style>
+        <p:txBody>
+          <a:bodyPr rtlCol="0" anchor="ctr" wrap="square" lIns="1143000" rIns="228600"/>
+          <a:lstStyle/>
+          <a:p>
+            <a:pPr algn="r" rtl="1"/>
+            <a:r>
+              <a:rPr sz="2600" b="1" lang="he-IL" altLang="en-US">
+                <a:solidFill>
+                  <a:srgbClr val="FFFFFF"/>
+                </a:solidFill>
+                <a:latin typeface="Arial"/>
+              </a:rPr>
+              <a:t>שיר</a:t>
+            </a:r>
+          </a:p>
+          <a:p>
+            <a:pPr algn="r" rtl="1"/>
+            <a:r>
+              <a:rPr sz="2000" b="0" lang="he-IL" altLang="en-US">
+                <a:solidFill>
+                  <a:srgbClr val="FFFFFF"/>
+                </a:solidFill>
+                <a:latin typeface="Arial"/>
+              </a:rPr>
+              <a:t>מילים בצד ימין</a:t>
+            </a:r>
+          </a:p>
+        </p:txBody>
+      </p:sp>
+      <p:sp>
+        <p:nvSpPr>
+          <p:cNvPr id="11" name="Oval 10"/>
+          <p:cNvSpPr/>
+          <p:nvPr/>
+        </p:nvSpPr>
+        <p:spPr>
+          <a:xfrm>
+            <a:off x="6492240" y="2194560"/>
+            <a:ext cx="640080" cy="640080"/>
+          </a:xfrm>
+          <a:prstGeom prst="ellipse">
+            <a:avLst/>
+          </a:prstGeom>
+          <a:solidFill>
+            <a:srgbClr val="FFFFFF"/>
+          </a:solidFill>
+          <a:ln>
+            <a:noFill/>
+          </a:ln>
+        </p:spPr>
+        <p:style>
+          <a:lnRef idx="1">
+            <a:schemeClr val="accent1"/>
+          </a:lnRef>
+          <a:fillRef idx="3">
+            <a:schemeClr val="accent1"/>
+          </a:fillRef>
+          <a:effectRef idx="2">
+            <a:schemeClr val="accent1"/>
+          </a:effectRef>
+          <a:fontRef idx="minor">
+            <a:schemeClr val="lt1"/>
+          </a:fontRef>
+        </p:style>
+        <p:txBody>
+          <a:bodyPr rtlCol="0" anchor="ctr"/>
+          <a:lstStyle/>
+          <a:p>
+            <a:pPr algn="ctr"/>
+          </a:p>
+        </p:txBody>
+      </p:sp>
+      <p:sp>
+        <p:nvSpPr>
+          <p:cNvPr id="12" name="Wave 11"/>
+          <p:cNvSpPr/>
+          <p:nvPr/>
+        </p:nvSpPr>
+        <p:spPr>
+          <a:xfrm>
+            <a:off x="6636258" y="2338578"/>
+            <a:ext cx="352044" cy="352044"/>
+          </a:xfrm>
+          <a:prstGeom prst="wave">
+            <a:avLst/>
+          </a:prstGeom>
+          <a:solidFill>
+            <a:srgbClr val="5C5E62"/>
+          </a:solidFill>
+          <a:ln>
+            <a:noFill/>
+          </a:ln>
+        </p:spPr>
+        <p:style>
+          <a:lnRef idx="1">
+            <a:schemeClr val="accent1"/>
+          </a:lnRef>
+          <a:fillRef idx="3">
+            <a:schemeClr val="accent1"/>
+          </a:fillRef>
+          <a:effectRef idx="2">
+            <a:schemeClr val="accent1"/>
+          </a:effectRef>
+          <a:fontRef idx="minor">
+            <a:schemeClr val="lt1"/>
+          </a:fontRef>
+        </p:style>
+        <p:txBody>
+          <a:bodyPr rtlCol="0" anchor="ctr"/>
+          <a:lstStyle/>
+          <a:p>
+            <a:pPr algn="ctr"/>
+          </a:p>
+        </p:txBody>
+      </p:sp>
+      <p:sp>
+        <p:nvSpPr>
+          <p:cNvPr id="13" name="Rounded Rectangle 12"/>
+          <p:cNvSpPr/>
+          <p:nvPr/>
+        </p:nvSpPr>
+        <p:spPr>
+          <a:xfrm>
+            <a:off x="9052560" y="1463040"/>
+            <a:ext cx="2651760" cy="2103120"/>
+          </a:xfrm>
+          <a:prstGeom prst="roundRect">
+            <a:avLst>
+              <a:gd name="adj" fmla="val 12000"/>
+            </a:avLst>
+          </a:prstGeom>
+          <a:solidFill>
+            <a:srgbClr val="A81018"/>
+          </a:solidFill>
+          <a:ln>
+            <a:noFill/>
+          </a:ln>
+        </p:spPr>
+        <p:style>
+          <a:lnRef idx="1">
+            <a:schemeClr val="accent1"/>
+          </a:lnRef>
+          <a:fillRef idx="3">
+            <a:schemeClr val="accent1"/>
+          </a:fillRef>
+          <a:effectRef idx="2">
+            <a:schemeClr val="accent1"/>
+          </a:effectRef>
+          <a:fontRef idx="minor">
+            <a:schemeClr val="lt1"/>
+          </a:fontRef>
+        </p:style>
+        <p:txBody>
+          <a:bodyPr rtlCol="0" anchor="ctr" wrap="square" lIns="1143000" rIns="228600"/>
+          <a:lstStyle/>
+          <a:p>
+            <a:pPr algn="r" rtl="1"/>
+            <a:r>
+              <a:rPr sz="2600" b="1" lang="he-IL" altLang="en-US">
+                <a:solidFill>
+                  <a:srgbClr val="FFFFFF"/>
+                </a:solidFill>
+                <a:latin typeface="Arial"/>
+              </a:rPr>
+              <a:t>שאלה</a:t>
+            </a:r>
+          </a:p>
+          <a:p>
+            <a:pPr algn="r" rtl="1"/>
+            <a:r>
+              <a:rPr sz="2000" b="0" lang="he-IL" altLang="en-US">
+                <a:solidFill>
+                  <a:srgbClr val="FFFFFF"/>
+                </a:solidFill>
+                <a:latin typeface="Arial"/>
+              </a:rPr>
+              <a:t>שאלה לדיון למטה</a:t>
+            </a:r>
+          </a:p>
+        </p:txBody>
+      </p:sp>
+      <p:sp>
+        <p:nvSpPr>
+          <p:cNvPr id="14" name="Oval 13"/>
+          <p:cNvSpPr/>
+          <p:nvPr/>
+        </p:nvSpPr>
+        <p:spPr>
+          <a:xfrm>
+            <a:off x="9326880" y="2194560"/>
+            <a:ext cx="640080" cy="640080"/>
+          </a:xfrm>
+          <a:prstGeom prst="ellipse">
+            <a:avLst/>
+          </a:prstGeom>
+          <a:solidFill>
+            <a:srgbClr val="FFFFFF"/>
+          </a:solidFill>
+          <a:ln>
+            <a:noFill/>
+          </a:ln>
+        </p:spPr>
+        <p:style>
+          <a:lnRef idx="1">
+            <a:schemeClr val="accent1"/>
+          </a:lnRef>
+          <a:fillRef idx="3">
+            <a:schemeClr val="accent1"/>
+          </a:fillRef>
+          <a:effectRef idx="2">
+            <a:schemeClr val="accent1"/>
+          </a:effectRef>
+          <a:fontRef idx="minor">
+            <a:schemeClr val="lt1"/>
+          </a:fontRef>
+        </p:style>
+        <p:txBody>
+          <a:bodyPr rtlCol="0" anchor="ctr"/>
+          <a:lstStyle/>
+          <a:p>
+            <a:pPr algn="ctr"/>
+          </a:p>
+        </p:txBody>
+      </p:sp>
+      <p:sp>
+        <p:nvSpPr>
+          <p:cNvPr id="15" name="Donut 14"/>
+          <p:cNvSpPr/>
+          <p:nvPr/>
+        </p:nvSpPr>
+        <p:spPr>
+          <a:xfrm>
+            <a:off x="9470898" y="2338578"/>
+            <a:ext cx="352044" cy="352044"/>
+          </a:xfrm>
+          <a:prstGeom prst="donut">
+            <a:avLst/>
+          </a:prstGeom>
+          <a:solidFill>
+            <a:srgbClr val="A81018"/>
+          </a:solidFill>
+          <a:ln>
+            <a:noFill/>
+          </a:ln>
+        </p:spPr>
+        <p:style>
+          <a:lnRef idx="1">
+            <a:schemeClr val="accent1"/>
+          </a:lnRef>
+          <a:fillRef idx="3">
+            <a:schemeClr val="accent1"/>
+          </a:fillRef>
+          <a:effectRef idx="2">
+            <a:schemeClr val="accent1"/>
+          </a:effectRef>
+          <a:fontRef idx="minor">
+            <a:schemeClr val="lt1"/>
+          </a:fontRef>
+        </p:style>
+        <p:txBody>
+          <a:bodyPr rtlCol="0" anchor="ctr"/>
+          <a:lstStyle/>
+          <a:p>
+            <a:pPr algn="ctr"/>
+          </a:p>
+        </p:txBody>
+      </p:sp>
+      <p:sp>
+        <p:nvSpPr>
+          <p:cNvPr id="16" name="TextBox 15"/>
+          <p:cNvSpPr txBox="1"/>
+          <p:nvPr/>
+        </p:nvSpPr>
+        <p:spPr>
+          <a:xfrm>
+            <a:off x="8412480" y="3840480"/>
+            <a:ext cx="3291840" cy="2743200"/>
+          </a:xfrm>
+          <a:prstGeom prst="rect">
+            <a:avLst/>
+          </a:prstGeom>
+          <a:noFill/>
+        </p:spPr>
+        <p:txBody>
+          <a:bodyPr wrap="square" anchor="t">
+            <a:spAutoFit/>
+          </a:bodyPr>
+          <a:lstStyle/>
+          <a:p>
+            <a:pPr algn="r" rtl="1">
+              <a:spcAft>
+                <a:spcPts val="1000"/>
+              </a:spcAft>
+            </a:pPr>
+            <a:r>
+              <a:rPr sz="2200" b="1" lang="he-IL" altLang="en-US">
+                <a:solidFill>
+                  <a:srgbClr val="171A20"/>
+                </a:solidFill>
+                <a:latin typeface="Arial"/>
+              </a:rPr>
+              <a:t>רכב אדום עולה על הרמפה,</a:t>
+            </a:r>
+          </a:p>
+          <a:p>
+            <a:pPr algn="r" rtl="1">
+              <a:spcAft>
+                <a:spcPts val="1000"/>
+              </a:spcAft>
+            </a:pPr>
+            <a:r>
+              <a:rPr sz="2200" b="1" lang="he-IL" altLang="en-US">
+                <a:solidFill>
+                  <a:srgbClr val="171A20"/>
+                </a:solidFill>
+                <a:latin typeface="Arial"/>
+              </a:rPr>
+              <a:t>מסתובב באוויר וחוזר לארץ.</a:t>
+            </a:r>
+          </a:p>
+          <a:p>
+            <a:pPr algn="r" rtl="1">
+              <a:spcAft>
+                <a:spcPts val="1000"/>
+              </a:spcAft>
+            </a:pPr>
+            <a:r>
+              <a:rPr sz="2200" b="1" lang="he-IL" altLang="en-US">
+                <a:solidFill>
+                  <a:srgbClr val="171A20"/>
+                </a:solidFill>
+                <a:latin typeface="Arial"/>
+              </a:rPr>
+              <a:t>טסלה וחלל חולמים יחד,</a:t>
+            </a:r>
+          </a:p>
+          <a:p>
+            <a:pPr algn="r" rtl="1">
+              <a:spcAft>
+                <a:spcPts val="1000"/>
+              </a:spcAft>
+            </a:pPr>
+            <a:r>
+              <a:rPr sz="2200" b="1" lang="he-IL" altLang="en-US">
+                <a:solidFill>
+                  <a:srgbClr val="171A20"/>
+                </a:solidFill>
+                <a:latin typeface="Arial"/>
+              </a:rPr>
+              <a:t>וכל ניסיון מלמד משהו חדש.</a:t>
+            </a:r>
+          </a:p>
+        </p:txBody>
+      </p:sp>
+      <p:sp>
+        <p:nvSpPr>
+          <p:cNvPr id="17" name="TextBox 16"/>
+          <p:cNvSpPr txBox="1"/>
+          <p:nvPr/>
+        </p:nvSpPr>
+        <p:spPr>
+          <a:xfrm>
+            <a:off x="548640" y="3931920"/>
+            <a:ext cx="7498079" cy="2377440"/>
+          </a:xfrm>
+          <a:prstGeom prst="rect">
+            <a:avLst/>
+          </a:prstGeom>
+          <a:noFill/>
+        </p:spPr>
+        <p:txBody>
+          <a:bodyPr wrap="square" anchor="t">
+            <a:spAutoFit/>
+          </a:bodyPr>
+          <a:lstStyle/>
+          <a:p>
+            <a:pPr algn="r" rtl="1">
+              <a:spcAft>
+                <a:spcPts val="1000"/>
+              </a:spcAft>
+            </a:pPr>
+            <a:r>
+              <a:rPr sz="2400" b="0" lang="he-IL" altLang="en-US">
+                <a:solidFill>
+                  <a:srgbClr val="171A20"/>
+                </a:solidFill>
+                <a:latin typeface="Arial"/>
+              </a:rPr>
+              <a:t>שיר קצר, מילים מקוריות של הכיתה. שירו את הבית על המנגינה שאתם אוהבים.</a:t>
+            </a:r>
+          </a:p>
+          <a:p>
+            <a:pPr algn="r" rtl="1">
+              <a:spcAft>
+                <a:spcPts val="1000"/>
+              </a:spcAft>
+            </a:pPr>
+            <a:r>
+              <a:rPr sz="2400" b="0" lang="he-IL" altLang="en-US">
+                <a:solidFill>
+                  <a:srgbClr val="171A20"/>
+                </a:solidFill>
+                <a:latin typeface="Arial"/>
+              </a:rPr>
+              <a:t>שאלה לדיון: מה הייתם שואלים את מאסק אם הייתם פוגשים אותו?</a:t>
             </a:r>
           </a:p>
         </p:txBody>

</xml_diff>